<commit_message>
chore: actualizar PPTX tal cual para descarga desde portada
</commit_message>
<xml_diff>
--- a/Presentacion_Anillo_Digital_y_Sensores_Tecnologicos.pptx
+++ b/Presentacion_Anillo_Digital_y_Sensores_Tecnologicos.pptx
@@ -257,7 +257,7 @@
       </p15:sldGuideLst>
     </p:ext>
     <p:ext uri="GoogleSlidesCustomDataVersion2">
-      <go:slidesCustomData xmlns:go="http://customooxmlschemas.google.com/" xmlns:ahyp="http://schemas.microsoft.com/office/drawing/2018/hyperlinkcolor" xmlns:p15="http://schemas.microsoft.com/office/powerpoint/2012/main" xmlns:p14="http://schemas.microsoft.com/office/powerpoint/2010/main" xmlns:com="http://schemas.openxmlformats.org/drawingml/2006/compatibility" xmlns:pvml="urn:schemas-microsoft-com:office:powerpoint" xmlns:v="urn:schemas-microsoft-com:vml" xmlns:o="urn:schemas-microsoft-com:office:office" xmlns:dgm="http://schemas.openxmlformats.org/drawingml/2006/diagram" xmlns:c="http://schemas.openxmlformats.org/drawingml/2006/chart" xmlns:mv="urn:schemas-microsoft-com:mac:vml" xmlns:mc="http://schemas.openxmlformats.org/markup-compatibility/2006" xmlns="" r:id="rId8" roundtripDataSignature="AMtx7mjVTY0SwYksGIJtVe/PY0KRRsAemg=="/>
+      <go:slidesCustomData xmlns="" xmlns:mc="http://schemas.openxmlformats.org/markup-compatibility/2006" xmlns:mv="urn:schemas-microsoft-com:mac:vml" xmlns:c="http://schemas.openxmlformats.org/drawingml/2006/chart" xmlns:dgm="http://schemas.openxmlformats.org/drawingml/2006/diagram" xmlns:o="urn:schemas-microsoft-com:office:office" xmlns:v="urn:schemas-microsoft-com:vml" xmlns:pvml="urn:schemas-microsoft-com:office:powerpoint" xmlns:com="http://schemas.openxmlformats.org/drawingml/2006/compatibility" xmlns:p14="http://schemas.microsoft.com/office/powerpoint/2010/main" xmlns:p15="http://schemas.microsoft.com/office/powerpoint/2012/main" xmlns:ahyp="http://schemas.microsoft.com/office/drawing/2018/hyperlinkcolor" xmlns:go="http://customooxmlschemas.google.com/" r:id="rId8" roundtripDataSignature="AMtx7mjVTY0SwYksGIJtVe/PY0KRRsAemg=="/>
     </p:ext>
   </p:extLst>
 </p:presentation>
@@ -10874,7 +10874,7 @@
         </p:nvSpPr>
         <p:spPr>
           <a:xfrm>
-            <a:off x="219075" y="703707"/>
+            <a:off x="189579" y="703707"/>
             <a:ext cx="5898000" cy="5898000"/>
           </a:xfrm>
           <a:prstGeom prst="roundRect">
@@ -11041,7 +11041,7 @@
               <a:buNone/>
             </a:pPr>
             <a:r>
-              <a:rPr lang="en-US" sz="700" b="0" i="1" u="none" strike="noStrike" cap="none">
+              <a:rPr lang="en-US" sz="700" b="0" i="1" u="none" strike="noStrike" cap="none" dirty="0" err="1">
                 <a:solidFill>
                   <a:srgbClr val="CFD7E7"/>
                 </a:solidFill>
@@ -11050,9 +11050,57 @@
                 <a:cs typeface="Calibri"/>
                 <a:sym typeface="Calibri"/>
               </a:rPr>
-              <a:t>Capacidades  •  Resultados 2025 vs 2026  •  Gráficos</a:t>
+              <a:t>Capacidades</a:t>
             </a:r>
-            <a:endParaRPr sz="1600">
+            <a:r>
+              <a:rPr lang="en-US" sz="700" b="0" i="1" u="none" strike="noStrike" cap="none" dirty="0">
+                <a:solidFill>
+                  <a:srgbClr val="CFD7E7"/>
+                </a:solidFill>
+                <a:latin typeface="Calibri"/>
+                <a:ea typeface="Calibri"/>
+                <a:cs typeface="Calibri"/>
+                <a:sym typeface="Calibri"/>
+              </a:rPr>
+              <a:t>  •  </a:t>
+            </a:r>
+            <a:r>
+              <a:rPr lang="en-US" sz="700" b="0" i="1" u="none" strike="noStrike" cap="none" dirty="0" err="1">
+                <a:solidFill>
+                  <a:srgbClr val="CFD7E7"/>
+                </a:solidFill>
+                <a:latin typeface="Calibri"/>
+                <a:ea typeface="Calibri"/>
+                <a:cs typeface="Calibri"/>
+                <a:sym typeface="Calibri"/>
+              </a:rPr>
+              <a:t>Resultados</a:t>
+            </a:r>
+            <a:r>
+              <a:rPr lang="en-US" sz="700" b="0" i="1" u="none" strike="noStrike" cap="none" dirty="0">
+                <a:solidFill>
+                  <a:srgbClr val="CFD7E7"/>
+                </a:solidFill>
+                <a:latin typeface="Calibri"/>
+                <a:ea typeface="Calibri"/>
+                <a:cs typeface="Calibri"/>
+                <a:sym typeface="Calibri"/>
+              </a:rPr>
+              <a:t> 2025 vs 2026  •  </a:t>
+            </a:r>
+            <a:r>
+              <a:rPr lang="en-US" sz="700" b="0" i="1" u="none" strike="noStrike" cap="none" dirty="0" err="1">
+                <a:solidFill>
+                  <a:srgbClr val="CFD7E7"/>
+                </a:solidFill>
+                <a:latin typeface="Calibri"/>
+                <a:ea typeface="Calibri"/>
+                <a:cs typeface="Calibri"/>
+                <a:sym typeface="Calibri"/>
+              </a:rPr>
+              <a:t>Gráficos</a:t>
+            </a:r>
+            <a:endParaRPr sz="1600" dirty="0">
               <a:solidFill>
                 <a:srgbClr val="CFD7E7"/>
               </a:solidFill>
@@ -11069,7 +11117,7 @@
         <p:spPr>
           <a:xfrm>
             <a:off x="338328" y="1280159"/>
-            <a:ext cx="5678424" cy="1145885"/>
+            <a:ext cx="5678424" cy="1215326"/>
           </a:xfrm>
           <a:prstGeom prst="roundRect">
             <a:avLst>
@@ -11181,7 +11229,7 @@
         </p:nvSpPr>
         <p:spPr>
           <a:xfrm>
-            <a:off x="393192" y="1481328"/>
+            <a:off x="393192" y="1648476"/>
             <a:ext cx="3051048" cy="863658"/>
           </a:xfrm>
           <a:prstGeom prst="rect">
@@ -11470,31 +11518,7 @@
                 <a:cs typeface="Calibri"/>
                 <a:sym typeface="Calibri"/>
               </a:rPr>
-              <a:t>•  254 </a:t>
-            </a:r>
-            <a:r>
-              <a:rPr lang="en-US" sz="800" b="1" i="0" u="none" strike="noStrike" cap="none" dirty="0" err="1">
-                <a:solidFill>
-                  <a:srgbClr val="E8F1F8"/>
-                </a:solidFill>
-                <a:latin typeface="Calibri"/>
-                <a:ea typeface="Calibri"/>
-                <a:cs typeface="Calibri"/>
-                <a:sym typeface="Calibri"/>
-              </a:rPr>
-              <a:t>efectivos</a:t>
-            </a:r>
-            <a:r>
-              <a:rPr lang="en-US" sz="800" b="1" i="0" u="none" strike="noStrike" cap="none">
-                <a:solidFill>
-                  <a:srgbClr val="E8F1F8"/>
-                </a:solidFill>
-                <a:latin typeface="Calibri"/>
-                <a:ea typeface="Calibri"/>
-                <a:cs typeface="Calibri"/>
-                <a:sym typeface="Calibri"/>
-              </a:rPr>
-              <a:t> (POLICIAL 154 – AUXILIAR 15 – CONTRATADO 84)</a:t>
+              <a:t>•  Personal: POLICIAL 154 – AUXILIAR 15 – CONTRATADO 84</a:t>
             </a:r>
             <a:endParaRPr sz="800" dirty="0"/>
           </a:p>
@@ -11508,8 +11532,8 @@
         </p:nvSpPr>
         <p:spPr>
           <a:xfrm>
-            <a:off x="3390900" y="1416558"/>
-            <a:ext cx="2651700" cy="754200"/>
+            <a:off x="3390900" y="1741026"/>
+            <a:ext cx="2651700" cy="778891"/>
           </a:xfrm>
           <a:prstGeom prst="rect">
             <a:avLst/>
@@ -11619,7 +11643,7 @@
                 <a:cs typeface="Calibri"/>
                 <a:sym typeface="Calibri"/>
               </a:rPr>
-              <a:t> legal</a:t>
+              <a:t> legal.</a:t>
             </a:r>
             <a:endParaRPr sz="1700" dirty="0"/>
           </a:p>
@@ -11742,7 +11766,7 @@
                 <a:cs typeface="Calibri"/>
                 <a:sym typeface="Calibri"/>
               </a:rPr>
-              <a:t> real</a:t>
+              <a:t> real.</a:t>
             </a:r>
             <a:endParaRPr sz="1700" dirty="0"/>
           </a:p>
@@ -11831,6 +11855,18 @@
               </a:rPr>
               <a:t>alarmas</a:t>
             </a:r>
+            <a:r>
+              <a:rPr lang="en-US" sz="900" b="0" i="0" u="none" strike="noStrike" cap="none" dirty="0">
+                <a:solidFill>
+                  <a:srgbClr val="B8B8B8"/>
+                </a:solidFill>
+                <a:latin typeface="Calibri"/>
+                <a:ea typeface="Calibri"/>
+                <a:cs typeface="Calibri"/>
+                <a:sym typeface="Calibri"/>
+              </a:rPr>
+              <a:t>.</a:t>
+            </a:r>
             <a:endParaRPr sz="1700" dirty="0"/>
           </a:p>
           <a:p>
@@ -11893,6 +11929,18 @@
                 <a:sym typeface="Calibri"/>
               </a:rPr>
               <a:t>interinstitucional</a:t>
+            </a:r>
+            <a:r>
+              <a:rPr lang="en-US" sz="900" b="0" i="0" u="none" strike="noStrike" cap="none" dirty="0">
+                <a:solidFill>
+                  <a:srgbClr val="B8B8B8"/>
+                </a:solidFill>
+                <a:latin typeface="Calibri"/>
+                <a:ea typeface="Calibri"/>
+                <a:cs typeface="Calibri"/>
+                <a:sym typeface="Calibri"/>
+              </a:rPr>
+              <a:t>.</a:t>
             </a:r>
             <a:endParaRPr sz="1700" dirty="0"/>
           </a:p>
@@ -11906,7 +11954,7 @@
         </p:nvSpPr>
         <p:spPr>
           <a:xfrm>
-            <a:off x="393192" y="2426045"/>
+            <a:off x="393192" y="2514535"/>
             <a:ext cx="4527600" cy="215400"/>
           </a:xfrm>
           <a:prstGeom prst="rect">
@@ -11933,7 +11981,7 @@
               <a:buNone/>
             </a:pPr>
             <a:r>
-              <a:rPr lang="en-US" sz="800" b="1" i="0" u="none" strike="noStrike" cap="none">
+              <a:rPr lang="en-US" sz="800" b="1" i="0" u="none" strike="noStrike" cap="none" dirty="0">
                 <a:solidFill>
                   <a:srgbClr val="7DC1E5"/>
                 </a:solidFill>
@@ -11944,7 +11992,7 @@
               </a:rPr>
               <a:t>📊  RESULTADOS 2025 vs 2026  •  ENE – AGO</a:t>
             </a:r>
-            <a:endParaRPr sz="1600"/>
+            <a:endParaRPr sz="1600" dirty="0"/>
           </a:p>
         </p:txBody>
       </p:sp>
@@ -11955,13 +12003,13 @@
           <p:nvPr>
             <p:extLst>
               <p:ext uri="{D42A27DB-BD31-4B8C-83A1-F6EECF244321}">
-                <p14:modId xmlns:p14="http://schemas.microsoft.com/office/powerpoint/2010/main" val="4173426416"/>
+                <p14:modId xmlns:p14="http://schemas.microsoft.com/office/powerpoint/2010/main" val="2945183212"/>
               </p:ext>
             </p:extLst>
           </p:nvPr>
         </p:nvGraphicFramePr>
         <p:xfrm>
-          <a:off x="942428" y="2654180"/>
+          <a:off x="942428" y="2742670"/>
           <a:ext cx="4231025" cy="1440250"/>
         </p:xfrm>
         <a:graphic>
@@ -12088,7 +12136,7 @@
                         <a:buNone/>
                       </a:pPr>
                       <a:r>
-                        <a:rPr lang="en-US" sz="750" b="1" u="none" strike="noStrike" cap="none">
+                        <a:rPr lang="en-US" sz="750" b="1" u="none" strike="noStrike" cap="none" dirty="0">
                           <a:solidFill>
                             <a:srgbClr val="7DC1E5"/>
                           </a:solidFill>
@@ -12099,7 +12147,7 @@
                         </a:rPr>
                         <a:t>2025</a:t>
                       </a:r>
-                      <a:endParaRPr sz="1600"/>
+                      <a:endParaRPr sz="1600" dirty="0"/>
                     </a:p>
                   </a:txBody>
                   <a:tcPr marL="27425" marR="27425" marT="45725" marB="45725" anchor="ctr">
@@ -13763,7 +13811,7 @@
                         <a:buNone/>
                       </a:pPr>
                       <a:r>
-                        <a:rPr lang="en-US" sz="750" u="none" strike="noStrike" cap="none">
+                        <a:rPr lang="en-US" sz="750" u="none" strike="noStrike" cap="none" dirty="0">
                           <a:solidFill>
                             <a:srgbClr val="E8F1F8"/>
                           </a:solidFill>
@@ -13772,9 +13820,33 @@
                           <a:cs typeface="Calibri"/>
                           <a:sym typeface="Calibri"/>
                         </a:rPr>
-                        <a:t>Prom. Incremento Personal</a:t>
+                        <a:t>Prom. </a:t>
                       </a:r>
-                      <a:endParaRPr sz="1600"/>
+                      <a:r>
+                        <a:rPr lang="en-US" sz="750" u="none" strike="noStrike" cap="none" dirty="0" err="1">
+                          <a:solidFill>
+                            <a:srgbClr val="E8F1F8"/>
+                          </a:solidFill>
+                          <a:latin typeface="Calibri"/>
+                          <a:ea typeface="Calibri"/>
+                          <a:cs typeface="Calibri"/>
+                          <a:sym typeface="Calibri"/>
+                        </a:rPr>
+                        <a:t>Incremento</a:t>
+                      </a:r>
+                      <a:r>
+                        <a:rPr lang="en-US" sz="750" u="none" strike="noStrike" cap="none" dirty="0">
+                          <a:solidFill>
+                            <a:srgbClr val="E8F1F8"/>
+                          </a:solidFill>
+                          <a:latin typeface="Calibri"/>
+                          <a:ea typeface="Calibri"/>
+                          <a:cs typeface="Calibri"/>
+                          <a:sym typeface="Calibri"/>
+                        </a:rPr>
+                        <a:t> Personal</a:t>
+                      </a:r>
+                      <a:endParaRPr sz="1600" dirty="0"/>
                     </a:p>
                   </a:txBody>
                   <a:tcPr marL="27425" marR="27425" marT="45725" marB="45725" anchor="ctr">
@@ -14050,7 +14122,7 @@
         </p:nvSpPr>
         <p:spPr>
           <a:xfrm>
-            <a:off x="338328" y="4105774"/>
+            <a:off x="338328" y="4194264"/>
             <a:ext cx="2802600" cy="200100"/>
           </a:xfrm>
           <a:prstGeom prst="rect">
@@ -14107,7 +14179,7 @@
         </p:blipFill>
         <p:spPr>
           <a:xfrm>
-            <a:off x="249425" y="4241875"/>
+            <a:off x="239593" y="4330365"/>
             <a:ext cx="2983174" cy="1333425"/>
           </a:xfrm>
           <a:prstGeom prst="rect">
@@ -14127,7 +14199,7 @@
         </p:nvSpPr>
         <p:spPr>
           <a:xfrm>
-            <a:off x="3214116" y="4105774"/>
+            <a:off x="3214116" y="4194264"/>
             <a:ext cx="2802600" cy="200100"/>
           </a:xfrm>
           <a:prstGeom prst="rect">
@@ -14184,7 +14256,7 @@
         </p:blipFill>
         <p:spPr>
           <a:xfrm>
-            <a:off x="3131575" y="4260925"/>
+            <a:off x="3121743" y="4349415"/>
             <a:ext cx="2913626" cy="1333425"/>
           </a:xfrm>
           <a:prstGeom prst="rect">
@@ -14204,7 +14276,7 @@
         </p:nvSpPr>
         <p:spPr>
           <a:xfrm>
-            <a:off x="338328" y="5680710"/>
+            <a:off x="338328" y="5788863"/>
             <a:ext cx="5678400" cy="777300"/>
           </a:xfrm>
           <a:prstGeom prst="roundRect">
@@ -14267,7 +14339,7 @@
         </p:nvSpPr>
         <p:spPr>
           <a:xfrm>
-            <a:off x="393192" y="5735574"/>
+            <a:off x="393192" y="5843727"/>
             <a:ext cx="5568600" cy="200100"/>
           </a:xfrm>
           <a:prstGeom prst="rect">
@@ -14317,8 +14389,8 @@
         </p:nvSpPr>
         <p:spPr>
           <a:xfrm>
-            <a:off x="393192" y="5863590"/>
-            <a:ext cx="5568600" cy="372000"/>
+            <a:off x="393192" y="5971743"/>
+            <a:ext cx="5568600" cy="549982"/>
           </a:xfrm>
           <a:prstGeom prst="rect">
             <a:avLst/>
@@ -14347,7 +14419,7 @@
               <a:buNone/>
             </a:pPr>
             <a:r>
-              <a:rPr lang="en-US" sz="800" b="0" i="0" u="none" strike="noStrike" cap="none">
+              <a:rPr lang="en-US" sz="800" b="0" i="0" u="none" strike="noStrike" cap="none" dirty="0">
                 <a:solidFill>
                   <a:srgbClr val="B8B8B8"/>
                 </a:solidFill>
@@ -14356,25 +14428,10 @@
                 <a:cs typeface="Calibri"/>
                 <a:sym typeface="Calibri"/>
               </a:rPr>
-              <a:t>▸  +163.8% alarmas atendidas por refuerzo de personal  •  +82.4% actuaciones por renovación de flota</a:t>
+              <a:t>▸  +163.8% </a:t>
             </a:r>
-            <a:endParaRPr sz="1600"/>
-          </a:p>
-          <a:p>
-            <a:pPr marL="0" marR="0" lvl="0" indent="0" algn="l" rtl="0">
-              <a:lnSpc>
-                <a:spcPct val="116666"/>
-              </a:lnSpc>
-              <a:spcBef>
-                <a:spcPts val="100"/>
-              </a:spcBef>
-              <a:spcAft>
-                <a:spcPts val="0"/>
-              </a:spcAft>
-              <a:buNone/>
-            </a:pPr>
             <a:r>
-              <a:rPr lang="en-US" sz="800" b="0" i="0" u="none" strike="noStrike" cap="none">
+              <a:rPr lang="en-US" sz="800" b="0" i="0" u="none" strike="noStrike" cap="none" dirty="0" err="1">
                 <a:solidFill>
                   <a:srgbClr val="B8B8B8"/>
                 </a:solidFill>
@@ -14383,9 +14440,363 @@
                 <a:cs typeface="Calibri"/>
                 <a:sym typeface="Calibri"/>
               </a:rPr>
-              <a:t>▸  🚁 Próximo paso: drones para seguimiento vehicular y cobertura aérea</a:t>
+              <a:t>alarmas</a:t>
             </a:r>
-            <a:endParaRPr sz="1600"/>
+            <a:r>
+              <a:rPr lang="en-US" sz="800" b="0" i="0" u="none" strike="noStrike" cap="none" dirty="0">
+                <a:solidFill>
+                  <a:srgbClr val="B8B8B8"/>
+                </a:solidFill>
+                <a:latin typeface="Calibri"/>
+                <a:ea typeface="Calibri"/>
+                <a:cs typeface="Calibri"/>
+                <a:sym typeface="Calibri"/>
+              </a:rPr>
+              <a:t> </a:t>
+            </a:r>
+            <a:r>
+              <a:rPr lang="en-US" sz="800" b="0" i="0" u="none" strike="noStrike" cap="none" dirty="0" err="1">
+                <a:solidFill>
+                  <a:srgbClr val="B8B8B8"/>
+                </a:solidFill>
+                <a:latin typeface="Calibri"/>
+                <a:ea typeface="Calibri"/>
+                <a:cs typeface="Calibri"/>
+                <a:sym typeface="Calibri"/>
+              </a:rPr>
+              <a:t>atendidas</a:t>
+            </a:r>
+            <a:r>
+              <a:rPr lang="en-US" sz="800" b="0" i="0" u="none" strike="noStrike" cap="none" dirty="0">
+                <a:solidFill>
+                  <a:srgbClr val="B8B8B8"/>
+                </a:solidFill>
+                <a:latin typeface="Calibri"/>
+                <a:ea typeface="Calibri"/>
+                <a:cs typeface="Calibri"/>
+                <a:sym typeface="Calibri"/>
+              </a:rPr>
+              <a:t> </a:t>
+            </a:r>
+            <a:r>
+              <a:rPr lang="en-US" sz="800" b="0" i="0" u="none" strike="noStrike" cap="none" dirty="0" err="1">
+                <a:solidFill>
+                  <a:srgbClr val="B8B8B8"/>
+                </a:solidFill>
+                <a:latin typeface="Calibri"/>
+                <a:ea typeface="Calibri"/>
+                <a:cs typeface="Calibri"/>
+                <a:sym typeface="Calibri"/>
+              </a:rPr>
+              <a:t>por</a:t>
+            </a:r>
+            <a:r>
+              <a:rPr lang="en-US" sz="800" b="0" i="0" u="none" strike="noStrike" cap="none" dirty="0">
+                <a:solidFill>
+                  <a:srgbClr val="B8B8B8"/>
+                </a:solidFill>
+                <a:latin typeface="Calibri"/>
+                <a:ea typeface="Calibri"/>
+                <a:cs typeface="Calibri"/>
+                <a:sym typeface="Calibri"/>
+              </a:rPr>
+              <a:t> </a:t>
+            </a:r>
+            <a:r>
+              <a:rPr lang="en-US" sz="800" b="0" i="0" u="none" strike="noStrike" cap="none" dirty="0" err="1">
+                <a:solidFill>
+                  <a:srgbClr val="B8B8B8"/>
+                </a:solidFill>
+                <a:latin typeface="Calibri"/>
+                <a:ea typeface="Calibri"/>
+                <a:cs typeface="Calibri"/>
+                <a:sym typeface="Calibri"/>
+              </a:rPr>
+              <a:t>refuerzo</a:t>
+            </a:r>
+            <a:r>
+              <a:rPr lang="en-US" sz="800" b="0" i="0" u="none" strike="noStrike" cap="none" dirty="0">
+                <a:solidFill>
+                  <a:srgbClr val="B8B8B8"/>
+                </a:solidFill>
+                <a:latin typeface="Calibri"/>
+                <a:ea typeface="Calibri"/>
+                <a:cs typeface="Calibri"/>
+                <a:sym typeface="Calibri"/>
+              </a:rPr>
+              <a:t> de personal  •  +82.4% </a:t>
+            </a:r>
+            <a:r>
+              <a:rPr lang="en-US" sz="800" b="0" i="0" u="none" strike="noStrike" cap="none" dirty="0" err="1">
+                <a:solidFill>
+                  <a:srgbClr val="B8B8B8"/>
+                </a:solidFill>
+                <a:latin typeface="Calibri"/>
+                <a:ea typeface="Calibri"/>
+                <a:cs typeface="Calibri"/>
+                <a:sym typeface="Calibri"/>
+              </a:rPr>
+              <a:t>actuaciones</a:t>
+            </a:r>
+            <a:r>
+              <a:rPr lang="en-US" sz="800" b="0" i="0" u="none" strike="noStrike" cap="none" dirty="0">
+                <a:solidFill>
+                  <a:srgbClr val="B8B8B8"/>
+                </a:solidFill>
+                <a:latin typeface="Calibri"/>
+                <a:ea typeface="Calibri"/>
+                <a:cs typeface="Calibri"/>
+                <a:sym typeface="Calibri"/>
+              </a:rPr>
+              <a:t> </a:t>
+            </a:r>
+            <a:r>
+              <a:rPr lang="en-US" sz="800" b="0" i="0" u="none" strike="noStrike" cap="none" dirty="0" err="1">
+                <a:solidFill>
+                  <a:srgbClr val="B8B8B8"/>
+                </a:solidFill>
+                <a:latin typeface="Calibri"/>
+                <a:ea typeface="Calibri"/>
+                <a:cs typeface="Calibri"/>
+                <a:sym typeface="Calibri"/>
+              </a:rPr>
+              <a:t>por</a:t>
+            </a:r>
+            <a:r>
+              <a:rPr lang="en-US" sz="800" b="0" i="0" u="none" strike="noStrike" cap="none" dirty="0">
+                <a:solidFill>
+                  <a:srgbClr val="B8B8B8"/>
+                </a:solidFill>
+                <a:latin typeface="Calibri"/>
+                <a:ea typeface="Calibri"/>
+                <a:cs typeface="Calibri"/>
+                <a:sym typeface="Calibri"/>
+              </a:rPr>
+              <a:t> </a:t>
+            </a:r>
+            <a:r>
+              <a:rPr lang="en-US" sz="800" b="0" i="0" u="none" strike="noStrike" cap="none" dirty="0" err="1">
+                <a:solidFill>
+                  <a:srgbClr val="B8B8B8"/>
+                </a:solidFill>
+                <a:latin typeface="Calibri"/>
+                <a:ea typeface="Calibri"/>
+                <a:cs typeface="Calibri"/>
+                <a:sym typeface="Calibri"/>
+              </a:rPr>
+              <a:t>renovación</a:t>
+            </a:r>
+            <a:r>
+              <a:rPr lang="en-US" sz="800" b="0" i="0" u="none" strike="noStrike" cap="none" dirty="0">
+                <a:solidFill>
+                  <a:srgbClr val="B8B8B8"/>
+                </a:solidFill>
+                <a:latin typeface="Calibri"/>
+                <a:ea typeface="Calibri"/>
+                <a:cs typeface="Calibri"/>
+                <a:sym typeface="Calibri"/>
+              </a:rPr>
+              <a:t> de </a:t>
+            </a:r>
+            <a:r>
+              <a:rPr lang="en-US" sz="800" b="0" i="0" u="none" strike="noStrike" cap="none" dirty="0" err="1">
+                <a:solidFill>
+                  <a:srgbClr val="B8B8B8"/>
+                </a:solidFill>
+                <a:latin typeface="Calibri"/>
+                <a:ea typeface="Calibri"/>
+                <a:cs typeface="Calibri"/>
+                <a:sym typeface="Calibri"/>
+              </a:rPr>
+              <a:t>flota</a:t>
+            </a:r>
+            <a:endParaRPr sz="1600" dirty="0"/>
+          </a:p>
+          <a:p>
+            <a:pPr lvl="0">
+              <a:lnSpc>
+                <a:spcPct val="116666"/>
+              </a:lnSpc>
+              <a:spcBef>
+                <a:spcPts val="100"/>
+              </a:spcBef>
+            </a:pPr>
+            <a:r>
+              <a:rPr lang="en-US" sz="800" b="0" i="0" u="none" strike="noStrike" cap="none" dirty="0">
+                <a:solidFill>
+                  <a:srgbClr val="B8B8B8"/>
+                </a:solidFill>
+                <a:latin typeface="Calibri"/>
+                <a:ea typeface="Calibri"/>
+                <a:cs typeface="Calibri"/>
+                <a:sym typeface="Calibri"/>
+              </a:rPr>
+              <a:t>▸  </a:t>
+            </a:r>
+            <a:r>
+              <a:rPr lang="en-US" sz="800" b="0" i="0" u="none" strike="noStrike" cap="none" dirty="0" err="1">
+                <a:solidFill>
+                  <a:srgbClr val="B8B8B8"/>
+                </a:solidFill>
+                <a:latin typeface="Calibri"/>
+                <a:ea typeface="Calibri"/>
+                <a:cs typeface="Calibri"/>
+                <a:sym typeface="Calibri"/>
+              </a:rPr>
+              <a:t>Próximo</a:t>
+            </a:r>
+            <a:r>
+              <a:rPr lang="en-US" sz="800" b="0" i="0" u="none" strike="noStrike" cap="none" dirty="0">
+                <a:solidFill>
+                  <a:srgbClr val="B8B8B8"/>
+                </a:solidFill>
+                <a:latin typeface="Calibri"/>
+                <a:ea typeface="Calibri"/>
+                <a:cs typeface="Calibri"/>
+                <a:sym typeface="Calibri"/>
+              </a:rPr>
+              <a:t> paso: </a:t>
+            </a:r>
+            <a:r>
+              <a:rPr lang="en-US" sz="800" dirty="0">
+                <a:solidFill>
+                  <a:srgbClr val="B8B8B8"/>
+                </a:solidFill>
+                <a:latin typeface="Calibri"/>
+                <a:ea typeface="Calibri"/>
+                <a:cs typeface="Calibri"/>
+                <a:sym typeface="Calibri"/>
+              </a:rPr>
+              <a:t>🚁 </a:t>
+            </a:r>
+            <a:r>
+              <a:rPr lang="en-US" sz="800" b="0" i="0" u="none" strike="noStrike" cap="none" dirty="0">
+                <a:solidFill>
+                  <a:srgbClr val="B8B8B8"/>
+                </a:solidFill>
+                <a:latin typeface="Calibri"/>
+                <a:ea typeface="Calibri"/>
+                <a:cs typeface="Calibri"/>
+                <a:sym typeface="Calibri"/>
+              </a:rPr>
+              <a:t>drones para </a:t>
+            </a:r>
+            <a:r>
+              <a:rPr lang="en-US" sz="800" b="0" i="0" u="none" strike="noStrike" cap="none" dirty="0" err="1">
+                <a:solidFill>
+                  <a:srgbClr val="B8B8B8"/>
+                </a:solidFill>
+                <a:latin typeface="Calibri"/>
+                <a:ea typeface="Calibri"/>
+                <a:cs typeface="Calibri"/>
+                <a:sym typeface="Calibri"/>
+              </a:rPr>
+              <a:t>seguimiento</a:t>
+            </a:r>
+            <a:r>
+              <a:rPr lang="en-US" sz="800" b="0" i="0" u="none" strike="noStrike" cap="none" dirty="0">
+                <a:solidFill>
+                  <a:srgbClr val="B8B8B8"/>
+                </a:solidFill>
+                <a:latin typeface="Calibri"/>
+                <a:ea typeface="Calibri"/>
+                <a:cs typeface="Calibri"/>
+                <a:sym typeface="Calibri"/>
+              </a:rPr>
+              <a:t> vehicular y </a:t>
+            </a:r>
+            <a:r>
+              <a:rPr lang="en-US" sz="800" b="0" i="0" u="none" strike="noStrike" cap="none" dirty="0" err="1">
+                <a:solidFill>
+                  <a:srgbClr val="B8B8B8"/>
+                </a:solidFill>
+                <a:latin typeface="Calibri"/>
+                <a:ea typeface="Calibri"/>
+                <a:cs typeface="Calibri"/>
+                <a:sym typeface="Calibri"/>
+              </a:rPr>
+              <a:t>cobertura</a:t>
+            </a:r>
+            <a:r>
+              <a:rPr lang="en-US" sz="800" b="0" i="0" u="none" strike="noStrike" cap="none" dirty="0">
+                <a:solidFill>
+                  <a:srgbClr val="B8B8B8"/>
+                </a:solidFill>
+                <a:latin typeface="Calibri"/>
+                <a:ea typeface="Calibri"/>
+                <a:cs typeface="Calibri"/>
+                <a:sym typeface="Calibri"/>
+              </a:rPr>
+              <a:t> </a:t>
+            </a:r>
+            <a:r>
+              <a:rPr lang="en-US" sz="800" b="0" i="0" u="none" strike="noStrike" cap="none" dirty="0" err="1">
+                <a:solidFill>
+                  <a:srgbClr val="B8B8B8"/>
+                </a:solidFill>
+                <a:latin typeface="Calibri"/>
+                <a:ea typeface="Calibri"/>
+                <a:cs typeface="Calibri"/>
+                <a:sym typeface="Calibri"/>
+              </a:rPr>
+              <a:t>aérea</a:t>
+            </a:r>
+            <a:endParaRPr lang="en-US" sz="800" b="0" i="0" u="none" strike="noStrike" cap="none" dirty="0">
+              <a:solidFill>
+                <a:srgbClr val="B8B8B8"/>
+              </a:solidFill>
+              <a:latin typeface="Calibri"/>
+              <a:ea typeface="Calibri"/>
+              <a:cs typeface="Calibri"/>
+              <a:sym typeface="Calibri"/>
+            </a:endParaRPr>
+          </a:p>
+          <a:p>
+            <a:pPr lvl="0">
+              <a:lnSpc>
+                <a:spcPct val="116666"/>
+              </a:lnSpc>
+              <a:spcBef>
+                <a:spcPts val="100"/>
+              </a:spcBef>
+            </a:pPr>
+            <a:r>
+              <a:rPr lang="en-US" sz="800" dirty="0">
+                <a:solidFill>
+                  <a:srgbClr val="B8B8B8"/>
+                </a:solidFill>
+                <a:latin typeface="Calibri"/>
+                <a:ea typeface="Calibri"/>
+                <a:cs typeface="Calibri"/>
+                <a:sym typeface="Calibri"/>
+              </a:rPr>
+              <a:t>▸ </a:t>
+            </a:r>
+            <a:r>
+              <a:rPr lang="en-US" sz="800" dirty="0" err="1">
+                <a:solidFill>
+                  <a:srgbClr val="B8B8B8"/>
+                </a:solidFill>
+                <a:latin typeface="Calibri"/>
+                <a:ea typeface="Calibri"/>
+                <a:cs typeface="Calibri"/>
+                <a:sym typeface="Calibri"/>
+              </a:rPr>
+              <a:t>Próximo</a:t>
+            </a:r>
+            <a:r>
+              <a:rPr lang="en-US" sz="800" dirty="0">
+                <a:solidFill>
+                  <a:srgbClr val="B8B8B8"/>
+                </a:solidFill>
+                <a:latin typeface="Calibri"/>
+                <a:ea typeface="Calibri"/>
+                <a:cs typeface="Calibri"/>
+                <a:sym typeface="Calibri"/>
+              </a:rPr>
+              <a:t> paso: </a:t>
+            </a:r>
+            <a:endParaRPr sz="800" dirty="0"/>
           </a:p>
         </p:txBody>
       </p:sp>
@@ -14397,7 +14808,7 @@
         </p:nvSpPr>
         <p:spPr>
           <a:xfrm>
-            <a:off x="6263640" y="713232"/>
+            <a:off x="6224312" y="713232"/>
             <a:ext cx="5897880" cy="5897880"/>
           </a:xfrm>
           <a:prstGeom prst="roundRect">
@@ -14558,14 +14969,14 @@
       </p:sp>
       <p:sp>
         <p:nvSpPr>
-          <p:cNvPr id="108" name="Google Shape;108;p1"/>
+          <p:cNvPr id="111" name="Google Shape;111;p1"/>
           <p:cNvSpPr/>
           <p:nvPr/>
         </p:nvSpPr>
         <p:spPr>
           <a:xfrm>
-            <a:off x="6373368" y="1280160"/>
-            <a:ext cx="2802636" cy="868680"/>
+            <a:off x="6373368" y="1280159"/>
+            <a:ext cx="5678424" cy="1220433"/>
           </a:xfrm>
           <a:prstGeom prst="roundRect">
             <a:avLst>
@@ -14621,233 +15032,13 @@
       </p:sp>
       <p:sp>
         <p:nvSpPr>
-          <p:cNvPr id="109" name="Google Shape;109;p1"/>
-          <p:cNvSpPr txBox="1"/>
-          <p:nvPr/>
-        </p:nvSpPr>
-        <p:spPr>
-          <a:xfrm>
-            <a:off x="6428232" y="1335024"/>
-            <a:ext cx="2692800" cy="230700"/>
-          </a:xfrm>
-          <a:prstGeom prst="rect">
-            <a:avLst/>
-          </a:prstGeom>
-          <a:noFill/>
-          <a:ln>
-            <a:noFill/>
-          </a:ln>
-        </p:spPr>
-        <p:txBody>
-          <a:bodyPr spcFirstLastPara="1" wrap="square" lIns="91425" tIns="45700" rIns="91425" bIns="45700" anchor="t" anchorCtr="0">
-            <a:spAutoFit/>
-          </a:bodyPr>
-          <a:lstStyle/>
-          <a:p>
-            <a:pPr marL="0" marR="0" lvl="0" indent="0" algn="l" rtl="0">
-              <a:spcBef>
-                <a:spcPts val="0"/>
-              </a:spcBef>
-              <a:spcAft>
-                <a:spcPts val="0"/>
-              </a:spcAft>
-              <a:buNone/>
-            </a:pPr>
-            <a:r>
-              <a:rPr lang="en-US" sz="900" b="1" i="0" u="none" strike="noStrike" cap="none">
-                <a:solidFill>
-                  <a:srgbClr val="7DC1E5"/>
-                </a:solidFill>
-                <a:latin typeface="Calibri"/>
-                <a:ea typeface="Calibri"/>
-                <a:cs typeface="Calibri"/>
-                <a:sym typeface="Calibri"/>
-              </a:rPr>
-              <a:t>👥  FUERZA EFECTIVA: 104 efectivos</a:t>
-            </a:r>
-            <a:endParaRPr sz="1700"/>
-          </a:p>
-        </p:txBody>
-      </p:sp>
-      <p:sp>
-        <p:nvSpPr>
-          <p:cNvPr id="110" name="Google Shape;110;p1"/>
-          <p:cNvSpPr txBox="1"/>
-          <p:nvPr/>
-        </p:nvSpPr>
-        <p:spPr>
-          <a:xfrm>
-            <a:off x="6373375" y="1481325"/>
-            <a:ext cx="2857500" cy="528300"/>
-          </a:xfrm>
-          <a:prstGeom prst="rect">
-            <a:avLst/>
-          </a:prstGeom>
-          <a:noFill/>
-          <a:ln>
-            <a:noFill/>
-          </a:ln>
-        </p:spPr>
-        <p:txBody>
-          <a:bodyPr spcFirstLastPara="1" wrap="square" lIns="91425" tIns="45700" rIns="91425" bIns="45700" anchor="t" anchorCtr="0">
-            <a:spAutoFit/>
-          </a:bodyPr>
-          <a:lstStyle/>
-          <a:p>
-            <a:pPr marL="0" marR="0" lvl="0" indent="0" algn="l" rtl="0">
-              <a:lnSpc>
-                <a:spcPct val="116666"/>
-              </a:lnSpc>
-              <a:spcBef>
-                <a:spcPts val="0"/>
-              </a:spcBef>
-              <a:spcAft>
-                <a:spcPts val="0"/>
-              </a:spcAft>
-              <a:buNone/>
-            </a:pPr>
-            <a:r>
-              <a:rPr lang="en-US" sz="800" b="1" i="0" u="none" strike="noStrike" cap="none">
-                <a:solidFill>
-                  <a:srgbClr val="E8F1F8"/>
-                </a:solidFill>
-                <a:latin typeface="Calibri"/>
-                <a:ea typeface="Calibri"/>
-                <a:cs typeface="Calibri"/>
-                <a:sym typeface="Calibri"/>
-              </a:rPr>
-              <a:t>▸  Posee 1 Centro de Monitoreo</a:t>
-            </a:r>
-            <a:endParaRPr sz="1600"/>
-          </a:p>
-          <a:p>
-            <a:pPr marL="0" marR="0" lvl="0" indent="0" algn="l" rtl="0">
-              <a:lnSpc>
-                <a:spcPct val="116666"/>
-              </a:lnSpc>
-              <a:spcBef>
-                <a:spcPts val="100"/>
-              </a:spcBef>
-              <a:spcAft>
-                <a:spcPts val="0"/>
-              </a:spcAft>
-              <a:buNone/>
-            </a:pPr>
-            <a:r>
-              <a:rPr lang="en-US" sz="800" b="0" i="0" u="none" strike="noStrike" cap="none">
-                <a:solidFill>
-                  <a:srgbClr val="B8B8B8"/>
-                </a:solidFill>
-                <a:latin typeface="Calibri"/>
-                <a:ea typeface="Calibri"/>
-                <a:cs typeface="Calibri"/>
-                <a:sym typeface="Calibri"/>
-              </a:rPr>
-              <a:t>▸  Gestión de Dispositivos Antipánico, Pulseras y Tobilleras</a:t>
-            </a:r>
-            <a:endParaRPr sz="1600"/>
-          </a:p>
-          <a:p>
-            <a:pPr marL="0" marR="0" lvl="0" indent="0" algn="l" rtl="0">
-              <a:lnSpc>
-                <a:spcPct val="116666"/>
-              </a:lnSpc>
-              <a:spcBef>
-                <a:spcPts val="100"/>
-              </a:spcBef>
-              <a:spcAft>
-                <a:spcPts val="0"/>
-              </a:spcAft>
-              <a:buNone/>
-            </a:pPr>
-            <a:r>
-              <a:rPr lang="en-US" sz="800" b="0" i="0" u="none" strike="noStrike" cap="none">
-                <a:solidFill>
-                  <a:srgbClr val="B8B8B8"/>
-                </a:solidFill>
-                <a:latin typeface="Calibri"/>
-                <a:ea typeface="Calibri"/>
-                <a:cs typeface="Calibri"/>
-                <a:sym typeface="Calibri"/>
-              </a:rPr>
-              <a:t>▸  Monitoreo de Dispositivos judicializados</a:t>
-            </a:r>
-            <a:endParaRPr sz="1600"/>
-          </a:p>
-        </p:txBody>
-      </p:sp>
-      <p:sp>
-        <p:nvSpPr>
-          <p:cNvPr id="111" name="Google Shape;111;p1"/>
-          <p:cNvSpPr/>
-          <p:nvPr/>
-        </p:nvSpPr>
-        <p:spPr>
-          <a:xfrm>
-            <a:off x="9249156" y="1280160"/>
-            <a:ext cx="2802636" cy="868680"/>
-          </a:xfrm>
-          <a:prstGeom prst="roundRect">
-            <a:avLst>
-              <a:gd name="adj" fmla="val 3000"/>
-            </a:avLst>
-          </a:prstGeom>
-          <a:solidFill>
-            <a:srgbClr val="121E2E"/>
-          </a:solidFill>
-          <a:ln w="9525" cap="flat" cmpd="sng">
-            <a:solidFill>
-              <a:srgbClr val="2373AA"/>
-            </a:solidFill>
-            <a:prstDash val="solid"/>
-            <a:round/>
-            <a:headEnd type="none" w="sm" len="sm"/>
-            <a:tailEnd type="none" w="sm" len="sm"/>
-          </a:ln>
-          <a:effectLst>
-            <a:outerShdw blurRad="40000" dist="23000" dir="5400000" rotWithShape="0">
-              <a:srgbClr val="000000">
-                <a:alpha val="34902"/>
-              </a:srgbClr>
-            </a:outerShdw>
-          </a:effectLst>
-        </p:spPr>
-        <p:txBody>
-          <a:bodyPr spcFirstLastPara="1" wrap="square" lIns="91425" tIns="45700" rIns="91425" bIns="45700" anchor="ctr" anchorCtr="0">
-            <a:noAutofit/>
-          </a:bodyPr>
-          <a:lstStyle/>
-          <a:p>
-            <a:pPr marL="0" marR="0" lvl="0" indent="0" algn="ctr" rtl="0">
-              <a:spcBef>
-                <a:spcPts val="0"/>
-              </a:spcBef>
-              <a:spcAft>
-                <a:spcPts val="0"/>
-              </a:spcAft>
-              <a:buNone/>
-            </a:pPr>
-            <a:endParaRPr sz="1800" b="0" i="0" u="none" strike="noStrike" cap="none">
-              <a:solidFill>
-                <a:schemeClr val="dk1"/>
-              </a:solidFill>
-              <a:latin typeface="Calibri"/>
-              <a:ea typeface="Calibri"/>
-              <a:cs typeface="Calibri"/>
-              <a:sym typeface="Calibri"/>
-            </a:endParaRPr>
-          </a:p>
-        </p:txBody>
-      </p:sp>
-      <p:sp>
-        <p:nvSpPr>
           <p:cNvPr id="112" name="Google Shape;112;p1"/>
           <p:cNvSpPr txBox="1"/>
           <p:nvPr/>
         </p:nvSpPr>
         <p:spPr>
           <a:xfrm>
-            <a:off x="9304020" y="1335024"/>
+            <a:off x="6334670" y="1335024"/>
             <a:ext cx="2692800" cy="223200"/>
           </a:xfrm>
           <a:prstGeom prst="rect">
@@ -14891,14 +15082,14 @@
       </p:sp>
       <p:sp>
         <p:nvSpPr>
-          <p:cNvPr id="113" name="Google Shape;113;p1"/>
+          <p:cNvPr id="114" name="Google Shape;114;p1"/>
           <p:cNvSpPr txBox="1"/>
           <p:nvPr/>
         </p:nvSpPr>
         <p:spPr>
           <a:xfrm>
-            <a:off x="9304020" y="1481328"/>
-            <a:ext cx="2692800" cy="200100"/>
+            <a:off x="6334669" y="1664208"/>
+            <a:ext cx="3458772" cy="681172"/>
           </a:xfrm>
           <a:prstGeom prst="rect">
             <a:avLst/>
@@ -14914,70 +15105,25 @@
           </a:bodyPr>
           <a:lstStyle/>
           <a:p>
-            <a:pPr marL="0" marR="0" lvl="0" indent="0" algn="l" rtl="0">
-              <a:spcBef>
-                <a:spcPts val="0"/>
-              </a:spcBef>
-              <a:spcAft>
-                <a:spcPts val="0"/>
-              </a:spcAft>
-              <a:buNone/>
+            <a:pPr>
+              <a:lnSpc>
+                <a:spcPct val="116666"/>
+              </a:lnSpc>
             </a:pPr>
             <a:r>
-              <a:rPr lang="en-US" sz="700" b="0" i="0" u="none" strike="noStrike" cap="none">
-                <a:solidFill>
-                  <a:srgbClr val="B8B8B8"/>
+              <a:rPr lang="en-US" sz="800" b="1" dirty="0">
+                <a:solidFill>
+                  <a:srgbClr val="E8F1F8"/>
                 </a:solidFill>
                 <a:latin typeface="Calibri"/>
                 <a:ea typeface="Calibri"/>
                 <a:cs typeface="Calibri"/>
                 <a:sym typeface="Calibri"/>
               </a:rPr>
-              <a:t>Depende del Dpto. Coordinación Operativa (art. 176°)</a:t>
+              <a:t>▸  Posee 1 Centro de </a:t>
             </a:r>
-            <a:endParaRPr sz="1600"/>
-          </a:p>
-        </p:txBody>
-      </p:sp>
-      <p:sp>
-        <p:nvSpPr>
-          <p:cNvPr id="114" name="Google Shape;114;p1"/>
-          <p:cNvSpPr txBox="1"/>
-          <p:nvPr/>
-        </p:nvSpPr>
-        <p:spPr>
-          <a:xfrm>
-            <a:off x="9304020" y="1664208"/>
-            <a:ext cx="2692800" cy="405300"/>
-          </a:xfrm>
-          <a:prstGeom prst="rect">
-            <a:avLst/>
-          </a:prstGeom>
-          <a:noFill/>
-          <a:ln>
-            <a:noFill/>
-          </a:ln>
-        </p:spPr>
-        <p:txBody>
-          <a:bodyPr spcFirstLastPara="1" wrap="square" lIns="91425" tIns="45700" rIns="91425" bIns="45700" anchor="t" anchorCtr="0">
-            <a:spAutoFit/>
-          </a:bodyPr>
-          <a:lstStyle/>
-          <a:p>
-            <a:pPr marL="0" marR="0" lvl="0" indent="0" algn="l" rtl="0">
-              <a:lnSpc>
-                <a:spcPct val="116666"/>
-              </a:lnSpc>
-              <a:spcBef>
-                <a:spcPts val="0"/>
-              </a:spcBef>
-              <a:spcAft>
-                <a:spcPts val="0"/>
-              </a:spcAft>
-              <a:buNone/>
-            </a:pPr>
             <a:r>
-              <a:rPr lang="en-US" sz="900" b="1" i="0" u="none" strike="noStrike" cap="none">
+              <a:rPr lang="en-US" sz="800" b="1" dirty="0" err="1">
                 <a:solidFill>
                   <a:srgbClr val="E8F1F8"/>
                 </a:solidFill>
@@ -14986,25 +15132,10 @@
                 <a:cs typeface="Calibri"/>
                 <a:sym typeface="Calibri"/>
               </a:rPr>
-              <a:t>▸  Sección Dispositivos Antipánico: 40</a:t>
+              <a:t>Monitoreo</a:t>
             </a:r>
-            <a:endParaRPr sz="1700"/>
-          </a:p>
-          <a:p>
-            <a:pPr marL="0" marR="0" lvl="0" indent="0" algn="l" rtl="0">
-              <a:lnSpc>
-                <a:spcPct val="116666"/>
-              </a:lnSpc>
-              <a:spcBef>
-                <a:spcPts val="100"/>
-              </a:spcBef>
-              <a:spcAft>
-                <a:spcPts val="0"/>
-              </a:spcAft>
-              <a:buNone/>
-            </a:pPr>
             <a:r>
-              <a:rPr lang="en-US" sz="900" b="1" i="0" u="none" strike="noStrike" cap="none">
+              <a:rPr lang="en-US" sz="800" b="1" dirty="0">
                 <a:solidFill>
                   <a:srgbClr val="E8F1F8"/>
                 </a:solidFill>
@@ -15013,9 +15144,335 @@
                 <a:cs typeface="Calibri"/>
                 <a:sym typeface="Calibri"/>
               </a:rPr>
-              <a:t>▸  Sección Pulseras y Tobilleras: 48</a:t>
+              <a:t>.</a:t>
             </a:r>
-            <a:endParaRPr sz="1700"/>
+          </a:p>
+          <a:p>
+            <a:pPr>
+              <a:lnSpc>
+                <a:spcPct val="116666"/>
+              </a:lnSpc>
+            </a:pPr>
+            <a:r>
+              <a:rPr lang="en-US" sz="800" b="1" dirty="0">
+                <a:solidFill>
+                  <a:srgbClr val="E8F1F8"/>
+                </a:solidFill>
+                <a:latin typeface="Calibri"/>
+                <a:ea typeface="Calibri"/>
+                <a:cs typeface="Calibri"/>
+                <a:sym typeface="Calibri"/>
+              </a:rPr>
+              <a:t>▸ División </a:t>
+            </a:r>
+            <a:r>
+              <a:rPr lang="en-US" sz="800" b="1" dirty="0" err="1">
+                <a:solidFill>
+                  <a:srgbClr val="E8F1F8"/>
+                </a:solidFill>
+                <a:latin typeface="Calibri"/>
+                <a:ea typeface="Calibri"/>
+                <a:cs typeface="Calibri"/>
+                <a:sym typeface="Calibri"/>
+              </a:rPr>
+              <a:t>Sensores</a:t>
+            </a:r>
+            <a:r>
+              <a:rPr lang="en-US" sz="800" b="1" dirty="0">
+                <a:solidFill>
+                  <a:srgbClr val="E8F1F8"/>
+                </a:solidFill>
+                <a:latin typeface="Calibri"/>
+                <a:ea typeface="Calibri"/>
+                <a:cs typeface="Calibri"/>
+                <a:sym typeface="Calibri"/>
+              </a:rPr>
+              <a:t> </a:t>
+            </a:r>
+            <a:r>
+              <a:rPr lang="en-US" sz="800" b="1" dirty="0" err="1">
+                <a:solidFill>
+                  <a:srgbClr val="E8F1F8"/>
+                </a:solidFill>
+                <a:latin typeface="Calibri"/>
+                <a:ea typeface="Calibri"/>
+                <a:cs typeface="Calibri"/>
+                <a:sym typeface="Calibri"/>
+              </a:rPr>
+              <a:t>Tecnológicos</a:t>
+            </a:r>
+            <a:r>
+              <a:rPr lang="en-US" sz="800" b="1" dirty="0">
+                <a:solidFill>
+                  <a:srgbClr val="E8F1F8"/>
+                </a:solidFill>
+                <a:latin typeface="Calibri"/>
+                <a:ea typeface="Calibri"/>
+                <a:cs typeface="Calibri"/>
+                <a:sym typeface="Calibri"/>
+              </a:rPr>
+              <a:t>: (Policial 11 – Auxiliar 5)</a:t>
+            </a:r>
+            <a:endParaRPr lang="en-US" sz="800" dirty="0"/>
+          </a:p>
+          <a:p>
+            <a:pPr lvl="0">
+              <a:lnSpc>
+                <a:spcPct val="116666"/>
+              </a:lnSpc>
+            </a:pPr>
+            <a:r>
+              <a:rPr lang="en-US" sz="800" b="1" i="0" u="none" strike="noStrike" cap="none" dirty="0">
+                <a:solidFill>
+                  <a:srgbClr val="E8F1F8"/>
+                </a:solidFill>
+                <a:latin typeface="Calibri"/>
+                <a:ea typeface="Calibri"/>
+                <a:cs typeface="Calibri"/>
+                <a:sym typeface="Calibri"/>
+              </a:rPr>
+              <a:t>▸  </a:t>
+            </a:r>
+            <a:r>
+              <a:rPr lang="en-US" sz="800" b="1" i="0" u="none" strike="noStrike" cap="none" dirty="0" err="1">
+                <a:solidFill>
+                  <a:srgbClr val="E8F1F8"/>
+                </a:solidFill>
+                <a:latin typeface="Calibri"/>
+                <a:ea typeface="Calibri"/>
+                <a:cs typeface="Calibri"/>
+                <a:sym typeface="Calibri"/>
+              </a:rPr>
+              <a:t>Sección</a:t>
+            </a:r>
+            <a:r>
+              <a:rPr lang="en-US" sz="800" b="1" i="0" u="none" strike="noStrike" cap="none" dirty="0">
+                <a:solidFill>
+                  <a:srgbClr val="E8F1F8"/>
+                </a:solidFill>
+                <a:latin typeface="Calibri"/>
+                <a:ea typeface="Calibri"/>
+                <a:cs typeface="Calibri"/>
+                <a:sym typeface="Calibri"/>
+              </a:rPr>
+              <a:t> </a:t>
+            </a:r>
+            <a:r>
+              <a:rPr lang="en-US" sz="800" b="1" i="0" u="none" strike="noStrike" cap="none" dirty="0" err="1">
+                <a:solidFill>
+                  <a:srgbClr val="E8F1F8"/>
+                </a:solidFill>
+                <a:latin typeface="Calibri"/>
+                <a:ea typeface="Calibri"/>
+                <a:cs typeface="Calibri"/>
+                <a:sym typeface="Calibri"/>
+              </a:rPr>
+              <a:t>Dispositivos</a:t>
+            </a:r>
+            <a:r>
+              <a:rPr lang="en-US" sz="800" b="1" i="0" u="none" strike="noStrike" cap="none" dirty="0">
+                <a:solidFill>
+                  <a:srgbClr val="E8F1F8"/>
+                </a:solidFill>
+                <a:latin typeface="Calibri"/>
+                <a:ea typeface="Calibri"/>
+                <a:cs typeface="Calibri"/>
+                <a:sym typeface="Calibri"/>
+              </a:rPr>
+              <a:t> </a:t>
+            </a:r>
+            <a:r>
+              <a:rPr lang="en-US" sz="800" b="1" i="0" u="none" strike="noStrike" cap="none" dirty="0" err="1">
+                <a:solidFill>
+                  <a:srgbClr val="E8F1F8"/>
+                </a:solidFill>
+                <a:latin typeface="Calibri"/>
+                <a:ea typeface="Calibri"/>
+                <a:cs typeface="Calibri"/>
+                <a:sym typeface="Calibri"/>
+              </a:rPr>
+              <a:t>Antipánico</a:t>
+            </a:r>
+            <a:r>
+              <a:rPr lang="en-US" sz="800" b="1" i="0" u="none" strike="noStrike" cap="none" dirty="0">
+                <a:solidFill>
+                  <a:srgbClr val="E8F1F8"/>
+                </a:solidFill>
+                <a:latin typeface="Calibri"/>
+                <a:ea typeface="Calibri"/>
+                <a:cs typeface="Calibri"/>
+                <a:sym typeface="Calibri"/>
+              </a:rPr>
+              <a:t>: </a:t>
+            </a:r>
+            <a:r>
+              <a:rPr lang="en-US" sz="800" b="1" dirty="0">
+                <a:solidFill>
+                  <a:srgbClr val="E8F1F8"/>
+                </a:solidFill>
+                <a:latin typeface="Calibri"/>
+                <a:ea typeface="Calibri"/>
+                <a:cs typeface="Calibri"/>
+                <a:sym typeface="Calibri"/>
+              </a:rPr>
+              <a:t>(Policial 5 – Auxiliar 15 – </a:t>
+            </a:r>
+            <a:r>
+              <a:rPr lang="en-US" sz="800" b="1" dirty="0" err="1">
+                <a:solidFill>
+                  <a:srgbClr val="E8F1F8"/>
+                </a:solidFill>
+                <a:latin typeface="Calibri"/>
+                <a:ea typeface="Calibri"/>
+                <a:cs typeface="Calibri"/>
+                <a:sym typeface="Calibri"/>
+              </a:rPr>
+              <a:t>Contratado</a:t>
+            </a:r>
+            <a:r>
+              <a:rPr lang="en-US" sz="800" b="1" dirty="0">
+                <a:solidFill>
+                  <a:srgbClr val="E8F1F8"/>
+                </a:solidFill>
+                <a:latin typeface="Calibri"/>
+                <a:ea typeface="Calibri"/>
+                <a:cs typeface="Calibri"/>
+                <a:sym typeface="Calibri"/>
+              </a:rPr>
+              <a:t> 20)</a:t>
+            </a:r>
+            <a:endParaRPr sz="800" dirty="0"/>
+          </a:p>
+          <a:p>
+            <a:pPr lvl="0">
+              <a:lnSpc>
+                <a:spcPct val="116666"/>
+              </a:lnSpc>
+              <a:spcBef>
+                <a:spcPts val="100"/>
+              </a:spcBef>
+            </a:pPr>
+            <a:r>
+              <a:rPr lang="en-US" sz="800" b="1" i="0" u="none" strike="noStrike" cap="none" dirty="0">
+                <a:solidFill>
+                  <a:srgbClr val="E8F1F8"/>
+                </a:solidFill>
+                <a:latin typeface="Calibri"/>
+                <a:ea typeface="Calibri"/>
+                <a:cs typeface="Calibri"/>
+                <a:sym typeface="Calibri"/>
+              </a:rPr>
+              <a:t>▸  </a:t>
+            </a:r>
+            <a:r>
+              <a:rPr lang="en-US" sz="800" b="1" i="0" u="none" strike="noStrike" cap="none" dirty="0" err="1">
+                <a:solidFill>
+                  <a:srgbClr val="E8F1F8"/>
+                </a:solidFill>
+                <a:latin typeface="Calibri"/>
+                <a:ea typeface="Calibri"/>
+                <a:cs typeface="Calibri"/>
+                <a:sym typeface="Calibri"/>
+              </a:rPr>
+              <a:t>Sección</a:t>
+            </a:r>
+            <a:r>
+              <a:rPr lang="en-US" sz="800" b="1" i="0" u="none" strike="noStrike" cap="none" dirty="0">
+                <a:solidFill>
+                  <a:srgbClr val="E8F1F8"/>
+                </a:solidFill>
+                <a:latin typeface="Calibri"/>
+                <a:ea typeface="Calibri"/>
+                <a:cs typeface="Calibri"/>
+                <a:sym typeface="Calibri"/>
+              </a:rPr>
+              <a:t> </a:t>
+            </a:r>
+            <a:r>
+              <a:rPr lang="en-US" sz="800" b="1" i="0" u="none" strike="noStrike" cap="none" dirty="0" err="1">
+                <a:solidFill>
+                  <a:srgbClr val="E8F1F8"/>
+                </a:solidFill>
+                <a:latin typeface="Calibri"/>
+                <a:ea typeface="Calibri"/>
+                <a:cs typeface="Calibri"/>
+                <a:sym typeface="Calibri"/>
+              </a:rPr>
+              <a:t>Pulseras</a:t>
+            </a:r>
+            <a:r>
+              <a:rPr lang="en-US" sz="800" b="1" i="0" u="none" strike="noStrike" cap="none" dirty="0">
+                <a:solidFill>
+                  <a:srgbClr val="E8F1F8"/>
+                </a:solidFill>
+                <a:latin typeface="Calibri"/>
+                <a:ea typeface="Calibri"/>
+                <a:cs typeface="Calibri"/>
+                <a:sym typeface="Calibri"/>
+              </a:rPr>
+              <a:t> y </a:t>
+            </a:r>
+            <a:r>
+              <a:rPr lang="en-US" sz="800" b="1" i="0" u="none" strike="noStrike" cap="none" dirty="0" err="1">
+                <a:solidFill>
+                  <a:srgbClr val="E8F1F8"/>
+                </a:solidFill>
+                <a:latin typeface="Calibri"/>
+                <a:ea typeface="Calibri"/>
+                <a:cs typeface="Calibri"/>
+                <a:sym typeface="Calibri"/>
+              </a:rPr>
+              <a:t>Tobilleras</a:t>
+            </a:r>
+            <a:r>
+              <a:rPr lang="en-US" sz="800" b="1" i="0" u="none" strike="noStrike" cap="none" dirty="0">
+                <a:solidFill>
+                  <a:srgbClr val="E8F1F8"/>
+                </a:solidFill>
+                <a:latin typeface="Calibri"/>
+                <a:ea typeface="Calibri"/>
+                <a:cs typeface="Calibri"/>
+                <a:sym typeface="Calibri"/>
+              </a:rPr>
+              <a:t>: </a:t>
+            </a:r>
+            <a:r>
+              <a:rPr lang="en-US" sz="800" b="1" dirty="0">
+                <a:solidFill>
+                  <a:srgbClr val="E8F1F8"/>
+                </a:solidFill>
+                <a:latin typeface="Calibri"/>
+                <a:ea typeface="Calibri"/>
+                <a:cs typeface="Calibri"/>
+                <a:sym typeface="Calibri"/>
+              </a:rPr>
+              <a:t>(Policial 6 – Auxiliar 11 – </a:t>
+            </a:r>
+            <a:r>
+              <a:rPr lang="en-US" sz="800" b="1" dirty="0" err="1">
+                <a:solidFill>
+                  <a:srgbClr val="E8F1F8"/>
+                </a:solidFill>
+                <a:latin typeface="Calibri"/>
+                <a:ea typeface="Calibri"/>
+                <a:cs typeface="Calibri"/>
+                <a:sym typeface="Calibri"/>
+              </a:rPr>
+              <a:t>Contratado</a:t>
+            </a:r>
+            <a:r>
+              <a:rPr lang="en-US" sz="800" b="1" dirty="0">
+                <a:solidFill>
+                  <a:srgbClr val="E8F1F8"/>
+                </a:solidFill>
+                <a:latin typeface="Calibri"/>
+                <a:ea typeface="Calibri"/>
+                <a:cs typeface="Calibri"/>
+                <a:sym typeface="Calibri"/>
+              </a:rPr>
+              <a:t> 31)</a:t>
+            </a:r>
+            <a:endParaRPr sz="800" dirty="0"/>
           </a:p>
         </p:txBody>
       </p:sp>
@@ -15027,7 +15484,7 @@
         </p:nvSpPr>
         <p:spPr>
           <a:xfrm>
-            <a:off x="6481318" y="2221992"/>
+            <a:off x="6481318" y="2516961"/>
             <a:ext cx="5678400" cy="215400"/>
           </a:xfrm>
           <a:prstGeom prst="rect">
@@ -15054,7 +15511,7 @@
               <a:buNone/>
             </a:pPr>
             <a:r>
-              <a:rPr lang="en-US" sz="800" b="1" i="0" u="none" strike="noStrike" cap="none">
+              <a:rPr lang="en-US" sz="800" b="1" i="0" u="none" strike="noStrike" cap="none" dirty="0">
                 <a:solidFill>
                   <a:srgbClr val="7DC1E5"/>
                 </a:solidFill>
@@ -15065,7 +15522,7 @@
               </a:rPr>
               <a:t>📊  RESULTADOS 2025 vs 2026  •  ENE – AGO</a:t>
             </a:r>
-            <a:endParaRPr sz="1600"/>
+            <a:endParaRPr sz="1600" dirty="0"/>
           </a:p>
         </p:txBody>
       </p:sp>
@@ -15073,10 +15530,16 @@
         <p:nvGraphicFramePr>
           <p:cNvPr id="116" name="Google Shape;116;p1"/>
           <p:cNvGraphicFramePr/>
-          <p:nvPr/>
+          <p:nvPr>
+            <p:extLst>
+              <p:ext uri="{D42A27DB-BD31-4B8C-83A1-F6EECF244321}">
+                <p14:modId xmlns:p14="http://schemas.microsoft.com/office/powerpoint/2010/main" val="1178421542"/>
+              </p:ext>
+            </p:extLst>
+          </p:nvPr>
         </p:nvGraphicFramePr>
         <p:xfrm>
-          <a:off x="6913118" y="2507996"/>
+          <a:off x="6913118" y="2802965"/>
           <a:ext cx="4069075" cy="1440250"/>
         </p:xfrm>
         <a:graphic>
@@ -16878,7 +17341,7 @@
                         <a:buNone/>
                       </a:pPr>
                       <a:r>
-                        <a:rPr lang="en-US" sz="750" u="none" strike="noStrike" cap="none">
+                        <a:rPr lang="en-US" sz="750" u="none" strike="noStrike" cap="none" dirty="0" err="1">
                           <a:solidFill>
                             <a:srgbClr val="E8F1F8"/>
                           </a:solidFill>
@@ -16887,9 +17350,69 @@
                           <a:cs typeface="Calibri"/>
                           <a:sym typeface="Calibri"/>
                         </a:rPr>
-                        <a:t>Detenidos Sec. Pulseras/Tobill.</a:t>
+                        <a:t>Detenidos</a:t>
                       </a:r>
-                      <a:endParaRPr sz="1600"/>
+                      <a:r>
+                        <a:rPr lang="en-US" sz="750" u="none" strike="noStrike" cap="none" dirty="0">
+                          <a:solidFill>
+                            <a:srgbClr val="E8F1F8"/>
+                          </a:solidFill>
+                          <a:latin typeface="Calibri"/>
+                          <a:ea typeface="Calibri"/>
+                          <a:cs typeface="Calibri"/>
+                          <a:sym typeface="Calibri"/>
+                        </a:rPr>
+                        <a:t> Sec. </a:t>
+                      </a:r>
+                      <a:r>
+                        <a:rPr lang="en-US" sz="750" u="none" strike="noStrike" cap="none" dirty="0" err="1">
+                          <a:solidFill>
+                            <a:srgbClr val="E8F1F8"/>
+                          </a:solidFill>
+                          <a:latin typeface="Calibri"/>
+                          <a:ea typeface="Calibri"/>
+                          <a:cs typeface="Calibri"/>
+                          <a:sym typeface="Calibri"/>
+                        </a:rPr>
+                        <a:t>Pulseras</a:t>
+                      </a:r>
+                      <a:r>
+                        <a:rPr lang="en-US" sz="750" u="none" strike="noStrike" cap="none" dirty="0">
+                          <a:solidFill>
+                            <a:srgbClr val="E8F1F8"/>
+                          </a:solidFill>
+                          <a:latin typeface="Calibri"/>
+                          <a:ea typeface="Calibri"/>
+                          <a:cs typeface="Calibri"/>
+                          <a:sym typeface="Calibri"/>
+                        </a:rPr>
+                        <a:t>/</a:t>
+                      </a:r>
+                      <a:r>
+                        <a:rPr lang="en-US" sz="750" u="none" strike="noStrike" cap="none" dirty="0" err="1">
+                          <a:solidFill>
+                            <a:srgbClr val="E8F1F8"/>
+                          </a:solidFill>
+                          <a:latin typeface="Calibri"/>
+                          <a:ea typeface="Calibri"/>
+                          <a:cs typeface="Calibri"/>
+                          <a:sym typeface="Calibri"/>
+                        </a:rPr>
+                        <a:t>Tobill</a:t>
+                      </a:r>
+                      <a:r>
+                        <a:rPr lang="en-US" sz="750" u="none" strike="noStrike" cap="none" dirty="0">
+                          <a:solidFill>
+                            <a:srgbClr val="E8F1F8"/>
+                          </a:solidFill>
+                          <a:latin typeface="Calibri"/>
+                          <a:ea typeface="Calibri"/>
+                          <a:cs typeface="Calibri"/>
+                          <a:sym typeface="Calibri"/>
+                        </a:rPr>
+                        <a:t>.</a:t>
+                      </a:r>
+                      <a:endParaRPr sz="1600" dirty="0"/>
                     </a:p>
                   </a:txBody>
                   <a:tcPr marL="27425" marR="27425" marT="45725" marB="45725" anchor="ctr">
@@ -17091,7 +17614,7 @@
                         <a:buNone/>
                       </a:pPr>
                       <a:r>
-                        <a:rPr lang="en-US" sz="750" b="1" u="none" strike="noStrike" cap="none">
+                        <a:rPr lang="en-US" sz="750" b="1" u="none" strike="noStrike" cap="none" dirty="0">
                           <a:solidFill>
                             <a:srgbClr val="4ADE80"/>
                           </a:solidFill>
@@ -17102,7 +17625,7 @@
                         </a:rPr>
                         <a:t>↑ 31.2%</a:t>
                       </a:r>
-                      <a:endParaRPr sz="1600"/>
+                      <a:endParaRPr sz="1600" dirty="0"/>
                     </a:p>
                   </a:txBody>
                   <a:tcPr marL="27425" marR="27425" marT="45725" marB="45725" anchor="ctr">
@@ -17165,7 +17688,7 @@
         </p:nvSpPr>
         <p:spPr>
           <a:xfrm>
-            <a:off x="6373368" y="4056888"/>
+            <a:off x="6373368" y="4253531"/>
             <a:ext cx="2802600" cy="200100"/>
           </a:xfrm>
           <a:prstGeom prst="rect">
@@ -17222,7 +17745,7 @@
         </p:blipFill>
         <p:spPr>
           <a:xfrm>
-            <a:off x="6290825" y="4208775"/>
+            <a:off x="6261329" y="4405418"/>
             <a:ext cx="2983174" cy="1333427"/>
           </a:xfrm>
           <a:prstGeom prst="rect">
@@ -17242,7 +17765,7 @@
         </p:nvSpPr>
         <p:spPr>
           <a:xfrm>
-            <a:off x="9249156" y="4056888"/>
+            <a:off x="9249156" y="4253531"/>
             <a:ext cx="2802600" cy="200100"/>
           </a:xfrm>
           <a:prstGeom prst="rect">
@@ -17299,7 +17822,7 @@
         </p:blipFill>
         <p:spPr>
           <a:xfrm>
-            <a:off x="9249150" y="4208775"/>
+            <a:off x="9077432" y="4428278"/>
             <a:ext cx="2983174" cy="1333416"/>
           </a:xfrm>
           <a:prstGeom prst="rect">
@@ -17319,7 +17842,7 @@
         </p:nvSpPr>
         <p:spPr>
           <a:xfrm>
-            <a:off x="6373368" y="5706110"/>
+            <a:off x="6373368" y="5814263"/>
             <a:ext cx="5678400" cy="777300"/>
           </a:xfrm>
           <a:prstGeom prst="roundRect">
@@ -17382,7 +17905,7 @@
         </p:nvSpPr>
         <p:spPr>
           <a:xfrm>
-            <a:off x="6428232" y="5760974"/>
+            <a:off x="6428232" y="5869127"/>
             <a:ext cx="5568600" cy="200100"/>
           </a:xfrm>
           <a:prstGeom prst="rect">
@@ -17409,7 +17932,7 @@
               <a:buNone/>
             </a:pPr>
             <a:r>
-              <a:rPr lang="en-US" sz="700" b="1" i="0" u="none" strike="noStrike" cap="none">
+              <a:rPr lang="en-US" sz="700" b="1" i="0" u="none" strike="noStrike" cap="none" dirty="0">
                 <a:solidFill>
                   <a:srgbClr val="7DC1E5"/>
                 </a:solidFill>
@@ -17418,9 +17941,45 @@
                 <a:cs typeface="Calibri"/>
                 <a:sym typeface="Calibri"/>
               </a:rPr>
-              <a:t>✅  CONCLUSIONES  •  Certificada ISO 9001:2015 — TÜV Rheinland</a:t>
+              <a:t>✅  CONCLUSIONES  •  </a:t>
             </a:r>
-            <a:endParaRPr sz="1600"/>
+            <a:r>
+              <a:rPr lang="en-US" sz="700" b="1" i="0" u="none" strike="noStrike" cap="none" dirty="0" err="1">
+                <a:solidFill>
+                  <a:srgbClr val="7DC1E5"/>
+                </a:solidFill>
+                <a:latin typeface="Calibri"/>
+                <a:ea typeface="Calibri"/>
+                <a:cs typeface="Calibri"/>
+                <a:sym typeface="Calibri"/>
+              </a:rPr>
+              <a:t>Certificada</a:t>
+            </a:r>
+            <a:r>
+              <a:rPr lang="en-US" sz="700" b="1" i="0" u="none" strike="noStrike" cap="none" dirty="0">
+                <a:solidFill>
+                  <a:srgbClr val="7DC1E5"/>
+                </a:solidFill>
+                <a:latin typeface="Calibri"/>
+                <a:ea typeface="Calibri"/>
+                <a:cs typeface="Calibri"/>
+                <a:sym typeface="Calibri"/>
+              </a:rPr>
+              <a:t> ISO 9001:2015 — TÜV </a:t>
+            </a:r>
+            <a:r>
+              <a:rPr lang="en-US" sz="700" b="1" i="0" u="none" strike="noStrike" cap="none" dirty="0" err="1">
+                <a:solidFill>
+                  <a:srgbClr val="7DC1E5"/>
+                </a:solidFill>
+                <a:latin typeface="Calibri"/>
+                <a:ea typeface="Calibri"/>
+                <a:cs typeface="Calibri"/>
+                <a:sym typeface="Calibri"/>
+              </a:rPr>
+              <a:t>Rheinland</a:t>
+            </a:r>
+            <a:endParaRPr sz="1600" dirty="0"/>
           </a:p>
         </p:txBody>
       </p:sp>
@@ -17432,7 +17991,7 @@
         </p:nvSpPr>
         <p:spPr>
           <a:xfrm>
-            <a:off x="6428232" y="5888990"/>
+            <a:off x="6428232" y="5997143"/>
             <a:ext cx="5568600" cy="372000"/>
           </a:xfrm>
           <a:prstGeom prst="rect">
@@ -17584,9 +18143,7 @@
             <a:srgbClr val="0A1218"/>
           </a:solidFill>
           <a:ln w="12700" cap="flat" cmpd="sng">
-            <a:solidFill>
-              <a:srgbClr val="2373AA"/>
-            </a:solidFill>
+            <a:noFill/>
             <a:prstDash val="solid"/>
             <a:round/>
             <a:headEnd type="none" w="sm" len="sm"/>
@@ -17601,6 +18158,564 @@
           </a:effectLst>
         </p:spPr>
       </p:pic>
+      <p:sp>
+        <p:nvSpPr>
+          <p:cNvPr id="3" name="Google Shape;109;p1">
+            <a:extLst>
+              <a:ext uri="{FF2B5EF4-FFF2-40B4-BE49-F238E27FC236}">
+                <a16:creationId xmlns:a16="http://schemas.microsoft.com/office/drawing/2014/main" id="{E4415A6B-AB2E-12D6-5FF9-64A99A8777E0}"/>
+              </a:ext>
+            </a:extLst>
+          </p:cNvPr>
+          <p:cNvSpPr txBox="1"/>
+          <p:nvPr/>
+        </p:nvSpPr>
+        <p:spPr>
+          <a:xfrm>
+            <a:off x="6328342" y="1469984"/>
+            <a:ext cx="2692800" cy="230700"/>
+          </a:xfrm>
+          <a:prstGeom prst="rect">
+            <a:avLst/>
+          </a:prstGeom>
+          <a:noFill/>
+          <a:ln>
+            <a:noFill/>
+          </a:ln>
+        </p:spPr>
+        <p:txBody>
+          <a:bodyPr spcFirstLastPara="1" wrap="square" lIns="91425" tIns="45700" rIns="91425" bIns="45700" anchor="t" anchorCtr="0">
+            <a:spAutoFit/>
+          </a:bodyPr>
+          <a:lstStyle/>
+          <a:p>
+            <a:pPr marL="0" marR="0" lvl="0" indent="0" algn="l" rtl="0">
+              <a:spcBef>
+                <a:spcPts val="0"/>
+              </a:spcBef>
+              <a:spcAft>
+                <a:spcPts val="0"/>
+              </a:spcAft>
+              <a:buNone/>
+            </a:pPr>
+            <a:r>
+              <a:rPr lang="en-US" sz="900" b="1" i="0" u="none" strike="noStrike" cap="none" dirty="0">
+                <a:solidFill>
+                  <a:srgbClr val="7DC1E5"/>
+                </a:solidFill>
+                <a:latin typeface="Calibri"/>
+                <a:ea typeface="Calibri"/>
+                <a:cs typeface="Calibri"/>
+                <a:sym typeface="Calibri"/>
+              </a:rPr>
+              <a:t>👥  FUERZA EFECTIVA: 104 </a:t>
+            </a:r>
+            <a:r>
+              <a:rPr lang="en-US" sz="900" b="1" i="0" u="none" strike="noStrike" cap="none" dirty="0" err="1">
+                <a:solidFill>
+                  <a:srgbClr val="7DC1E5"/>
+                </a:solidFill>
+                <a:latin typeface="Calibri"/>
+                <a:ea typeface="Calibri"/>
+                <a:cs typeface="Calibri"/>
+                <a:sym typeface="Calibri"/>
+              </a:rPr>
+              <a:t>efectivos</a:t>
+            </a:r>
+            <a:endParaRPr sz="1700" dirty="0"/>
+          </a:p>
+        </p:txBody>
+      </p:sp>
+      <p:sp>
+        <p:nvSpPr>
+          <p:cNvPr id="5" name="Google Shape;110;p1">
+            <a:extLst>
+              <a:ext uri="{FF2B5EF4-FFF2-40B4-BE49-F238E27FC236}">
+                <a16:creationId xmlns:a16="http://schemas.microsoft.com/office/drawing/2014/main" id="{3E569B3A-D02C-72A3-86F6-1A189EEDD924}"/>
+              </a:ext>
+            </a:extLst>
+          </p:cNvPr>
+          <p:cNvSpPr txBox="1"/>
+          <p:nvPr/>
+        </p:nvSpPr>
+        <p:spPr>
+          <a:xfrm>
+            <a:off x="9793441" y="1852261"/>
+            <a:ext cx="2400427" cy="549982"/>
+          </a:xfrm>
+          <a:prstGeom prst="rect">
+            <a:avLst/>
+          </a:prstGeom>
+          <a:noFill/>
+          <a:ln>
+            <a:noFill/>
+          </a:ln>
+        </p:spPr>
+        <p:txBody>
+          <a:bodyPr spcFirstLastPara="1" wrap="square" lIns="91425" tIns="45700" rIns="91425" bIns="45700" anchor="t" anchorCtr="0">
+            <a:spAutoFit/>
+          </a:bodyPr>
+          <a:lstStyle/>
+          <a:p>
+            <a:pPr marL="0" marR="0" lvl="0" indent="0" algn="l" rtl="0">
+              <a:lnSpc>
+                <a:spcPct val="116666"/>
+              </a:lnSpc>
+              <a:spcBef>
+                <a:spcPts val="100"/>
+              </a:spcBef>
+              <a:spcAft>
+                <a:spcPts val="0"/>
+              </a:spcAft>
+              <a:buNone/>
+            </a:pPr>
+            <a:r>
+              <a:rPr lang="en-US" sz="800" b="0" i="0" u="none" strike="noStrike" cap="none" dirty="0">
+                <a:solidFill>
+                  <a:srgbClr val="B8B8B8"/>
+                </a:solidFill>
+                <a:latin typeface="Calibri"/>
+                <a:ea typeface="Calibri"/>
+                <a:cs typeface="Calibri"/>
+                <a:sym typeface="Calibri"/>
+              </a:rPr>
+              <a:t>▸  </a:t>
+            </a:r>
+            <a:r>
+              <a:rPr lang="en-US" sz="800" b="0" i="0" u="none" strike="noStrike" cap="none" dirty="0" err="1">
+                <a:solidFill>
+                  <a:srgbClr val="B8B8B8"/>
+                </a:solidFill>
+                <a:latin typeface="Calibri"/>
+                <a:ea typeface="Calibri"/>
+                <a:cs typeface="Calibri"/>
+                <a:sym typeface="Calibri"/>
+              </a:rPr>
+              <a:t>Gestión</a:t>
+            </a:r>
+            <a:r>
+              <a:rPr lang="en-US" sz="800" b="0" i="0" u="none" strike="noStrike" cap="none" dirty="0">
+                <a:solidFill>
+                  <a:srgbClr val="B8B8B8"/>
+                </a:solidFill>
+                <a:latin typeface="Calibri"/>
+                <a:ea typeface="Calibri"/>
+                <a:cs typeface="Calibri"/>
+                <a:sym typeface="Calibri"/>
+              </a:rPr>
+              <a:t> de </a:t>
+            </a:r>
+            <a:r>
+              <a:rPr lang="en-US" sz="800" b="0" i="0" u="none" strike="noStrike" cap="none" dirty="0" err="1">
+                <a:solidFill>
+                  <a:srgbClr val="B8B8B8"/>
+                </a:solidFill>
+                <a:latin typeface="Calibri"/>
+                <a:ea typeface="Calibri"/>
+                <a:cs typeface="Calibri"/>
+                <a:sym typeface="Calibri"/>
+              </a:rPr>
+              <a:t>Dispositivos</a:t>
+            </a:r>
+            <a:r>
+              <a:rPr lang="en-US" sz="800" b="0" i="0" u="none" strike="noStrike" cap="none" dirty="0">
+                <a:solidFill>
+                  <a:srgbClr val="B8B8B8"/>
+                </a:solidFill>
+                <a:latin typeface="Calibri"/>
+                <a:ea typeface="Calibri"/>
+                <a:cs typeface="Calibri"/>
+                <a:sym typeface="Calibri"/>
+              </a:rPr>
+              <a:t> </a:t>
+            </a:r>
+            <a:r>
+              <a:rPr lang="en-US" sz="800" b="0" i="0" u="none" strike="noStrike" cap="none" dirty="0" err="1">
+                <a:solidFill>
+                  <a:srgbClr val="B8B8B8"/>
+                </a:solidFill>
+                <a:latin typeface="Calibri"/>
+                <a:ea typeface="Calibri"/>
+                <a:cs typeface="Calibri"/>
+                <a:sym typeface="Calibri"/>
+              </a:rPr>
+              <a:t>Antipánico</a:t>
+            </a:r>
+            <a:r>
+              <a:rPr lang="en-US" sz="800" b="0" i="0" u="none" strike="noStrike" cap="none" dirty="0">
+                <a:solidFill>
+                  <a:srgbClr val="B8B8B8"/>
+                </a:solidFill>
+                <a:latin typeface="Calibri"/>
+                <a:ea typeface="Calibri"/>
+                <a:cs typeface="Calibri"/>
+                <a:sym typeface="Calibri"/>
+              </a:rPr>
+              <a:t>, </a:t>
+            </a:r>
+            <a:r>
+              <a:rPr lang="en-US" sz="800" b="0" i="0" u="none" strike="noStrike" cap="none" dirty="0" err="1">
+                <a:solidFill>
+                  <a:srgbClr val="B8B8B8"/>
+                </a:solidFill>
+                <a:latin typeface="Calibri"/>
+                <a:ea typeface="Calibri"/>
+                <a:cs typeface="Calibri"/>
+                <a:sym typeface="Calibri"/>
+              </a:rPr>
+              <a:t>Pulseras</a:t>
+            </a:r>
+            <a:r>
+              <a:rPr lang="en-US" sz="800" b="0" i="0" u="none" strike="noStrike" cap="none" dirty="0">
+                <a:solidFill>
+                  <a:srgbClr val="B8B8B8"/>
+                </a:solidFill>
+                <a:latin typeface="Calibri"/>
+                <a:ea typeface="Calibri"/>
+                <a:cs typeface="Calibri"/>
+                <a:sym typeface="Calibri"/>
+              </a:rPr>
+              <a:t> y </a:t>
+            </a:r>
+            <a:r>
+              <a:rPr lang="en-US" sz="800" b="0" i="0" u="none" strike="noStrike" cap="none" dirty="0" err="1">
+                <a:solidFill>
+                  <a:srgbClr val="B8B8B8"/>
+                </a:solidFill>
+                <a:latin typeface="Calibri"/>
+                <a:ea typeface="Calibri"/>
+                <a:cs typeface="Calibri"/>
+                <a:sym typeface="Calibri"/>
+              </a:rPr>
+              <a:t>Tobilleras</a:t>
+            </a:r>
+            <a:r>
+              <a:rPr lang="en-US" sz="800" b="0" i="0" u="none" strike="noStrike" cap="none" dirty="0">
+                <a:solidFill>
+                  <a:srgbClr val="B8B8B8"/>
+                </a:solidFill>
+                <a:latin typeface="Calibri"/>
+                <a:ea typeface="Calibri"/>
+                <a:cs typeface="Calibri"/>
+                <a:sym typeface="Calibri"/>
+              </a:rPr>
+              <a:t>.</a:t>
+            </a:r>
+            <a:endParaRPr sz="1600" dirty="0"/>
+          </a:p>
+          <a:p>
+            <a:pPr marL="0" marR="0" lvl="0" indent="0" algn="l" rtl="0">
+              <a:lnSpc>
+                <a:spcPct val="116666"/>
+              </a:lnSpc>
+              <a:spcBef>
+                <a:spcPts val="100"/>
+              </a:spcBef>
+              <a:spcAft>
+                <a:spcPts val="0"/>
+              </a:spcAft>
+              <a:buNone/>
+            </a:pPr>
+            <a:r>
+              <a:rPr lang="en-US" sz="800" b="0" i="0" u="none" strike="noStrike" cap="none" dirty="0">
+                <a:solidFill>
+                  <a:srgbClr val="B8B8B8"/>
+                </a:solidFill>
+                <a:latin typeface="Calibri"/>
+                <a:ea typeface="Calibri"/>
+                <a:cs typeface="Calibri"/>
+                <a:sym typeface="Calibri"/>
+              </a:rPr>
+              <a:t>▸  </a:t>
+            </a:r>
+            <a:r>
+              <a:rPr lang="en-US" sz="800" b="0" i="0" u="none" strike="noStrike" cap="none" dirty="0" err="1">
+                <a:solidFill>
+                  <a:srgbClr val="B8B8B8"/>
+                </a:solidFill>
+                <a:latin typeface="Calibri"/>
+                <a:ea typeface="Calibri"/>
+                <a:cs typeface="Calibri"/>
+                <a:sym typeface="Calibri"/>
+              </a:rPr>
+              <a:t>Monitoreo</a:t>
+            </a:r>
+            <a:r>
+              <a:rPr lang="en-US" sz="800" b="0" i="0" u="none" strike="noStrike" cap="none" dirty="0">
+                <a:solidFill>
+                  <a:srgbClr val="B8B8B8"/>
+                </a:solidFill>
+                <a:latin typeface="Calibri"/>
+                <a:ea typeface="Calibri"/>
+                <a:cs typeface="Calibri"/>
+                <a:sym typeface="Calibri"/>
+              </a:rPr>
+              <a:t> de </a:t>
+            </a:r>
+            <a:r>
+              <a:rPr lang="en-US" sz="800" b="0" i="0" u="none" strike="noStrike" cap="none" dirty="0" err="1">
+                <a:solidFill>
+                  <a:srgbClr val="B8B8B8"/>
+                </a:solidFill>
+                <a:latin typeface="Calibri"/>
+                <a:ea typeface="Calibri"/>
+                <a:cs typeface="Calibri"/>
+                <a:sym typeface="Calibri"/>
+              </a:rPr>
+              <a:t>Dispositivos</a:t>
+            </a:r>
+            <a:r>
+              <a:rPr lang="en-US" sz="800" b="0" i="0" u="none" strike="noStrike" cap="none" dirty="0">
+                <a:solidFill>
+                  <a:srgbClr val="B8B8B8"/>
+                </a:solidFill>
+                <a:latin typeface="Calibri"/>
+                <a:ea typeface="Calibri"/>
+                <a:cs typeface="Calibri"/>
+                <a:sym typeface="Calibri"/>
+              </a:rPr>
+              <a:t> </a:t>
+            </a:r>
+            <a:r>
+              <a:rPr lang="en-US" sz="800" b="0" i="0" u="none" strike="noStrike" cap="none" dirty="0" err="1">
+                <a:solidFill>
+                  <a:srgbClr val="B8B8B8"/>
+                </a:solidFill>
+                <a:latin typeface="Calibri"/>
+                <a:ea typeface="Calibri"/>
+                <a:cs typeface="Calibri"/>
+                <a:sym typeface="Calibri"/>
+              </a:rPr>
+              <a:t>judicializados</a:t>
+            </a:r>
+            <a:r>
+              <a:rPr lang="en-US" sz="800" b="0" i="0" u="none" strike="noStrike" cap="none">
+                <a:solidFill>
+                  <a:srgbClr val="B8B8B8"/>
+                </a:solidFill>
+                <a:latin typeface="Calibri"/>
+                <a:ea typeface="Calibri"/>
+                <a:cs typeface="Calibri"/>
+                <a:sym typeface="Calibri"/>
+              </a:rPr>
+              <a:t>.</a:t>
+            </a:r>
+            <a:endParaRPr sz="1600" dirty="0"/>
+          </a:p>
+        </p:txBody>
+      </p:sp>
+      <p:sp>
+        <p:nvSpPr>
+          <p:cNvPr id="11" name="Google Shape;109;p1">
+            <a:extLst>
+              <a:ext uri="{FF2B5EF4-FFF2-40B4-BE49-F238E27FC236}">
+                <a16:creationId xmlns:a16="http://schemas.microsoft.com/office/drawing/2014/main" id="{00D7B72D-A1EA-3AA0-1FF8-45E803D4D0DE}"/>
+              </a:ext>
+            </a:extLst>
+          </p:cNvPr>
+          <p:cNvSpPr txBox="1"/>
+          <p:nvPr/>
+        </p:nvSpPr>
+        <p:spPr>
+          <a:xfrm>
+            <a:off x="402300" y="1454500"/>
+            <a:ext cx="2692800" cy="230700"/>
+          </a:xfrm>
+          <a:prstGeom prst="rect">
+            <a:avLst/>
+          </a:prstGeom>
+          <a:noFill/>
+          <a:ln>
+            <a:noFill/>
+          </a:ln>
+        </p:spPr>
+        <p:txBody>
+          <a:bodyPr spcFirstLastPara="1" wrap="square" lIns="91425" tIns="45700" rIns="91425" bIns="45700" anchor="t" anchorCtr="0">
+            <a:spAutoFit/>
+          </a:bodyPr>
+          <a:lstStyle/>
+          <a:p>
+            <a:pPr marL="0" marR="0" lvl="0" indent="0" algn="l" rtl="0">
+              <a:spcBef>
+                <a:spcPts val="0"/>
+              </a:spcBef>
+              <a:spcAft>
+                <a:spcPts val="0"/>
+              </a:spcAft>
+              <a:buNone/>
+            </a:pPr>
+            <a:r>
+              <a:rPr lang="en-US" sz="900" b="1" i="0" u="none" strike="noStrike" cap="none" dirty="0">
+                <a:solidFill>
+                  <a:srgbClr val="7DC1E5"/>
+                </a:solidFill>
+                <a:latin typeface="Calibri"/>
+                <a:ea typeface="Calibri"/>
+                <a:cs typeface="Calibri"/>
+                <a:sym typeface="Calibri"/>
+              </a:rPr>
+              <a:t>👥  FUERZA EFECTIVA: 253 </a:t>
+            </a:r>
+            <a:r>
+              <a:rPr lang="en-US" sz="900" b="1" i="0" u="none" strike="noStrike" cap="none" dirty="0" err="1">
+                <a:solidFill>
+                  <a:srgbClr val="7DC1E5"/>
+                </a:solidFill>
+                <a:latin typeface="Calibri"/>
+                <a:ea typeface="Calibri"/>
+                <a:cs typeface="Calibri"/>
+                <a:sym typeface="Calibri"/>
+              </a:rPr>
+              <a:t>efectivos</a:t>
+            </a:r>
+            <a:endParaRPr sz="1700" dirty="0"/>
+          </a:p>
+        </p:txBody>
+      </p:sp>
+      <p:sp>
+        <p:nvSpPr>
+          <p:cNvPr id="13" name="Google Shape;109;p1">
+            <a:extLst>
+              <a:ext uri="{FF2B5EF4-FFF2-40B4-BE49-F238E27FC236}">
+                <a16:creationId xmlns:a16="http://schemas.microsoft.com/office/drawing/2014/main" id="{D8416C00-0E98-101B-AE40-479EC96A7AC9}"/>
+              </a:ext>
+            </a:extLst>
+          </p:cNvPr>
+          <p:cNvSpPr txBox="1"/>
+          <p:nvPr/>
+        </p:nvSpPr>
+        <p:spPr>
+          <a:xfrm>
+            <a:off x="3337236" y="1587238"/>
+            <a:ext cx="2692800" cy="230700"/>
+          </a:xfrm>
+          <a:prstGeom prst="rect">
+            <a:avLst/>
+          </a:prstGeom>
+          <a:noFill/>
+          <a:ln>
+            <a:noFill/>
+          </a:ln>
+        </p:spPr>
+        <p:txBody>
+          <a:bodyPr spcFirstLastPara="1" wrap="square" lIns="91425" tIns="45700" rIns="91425" bIns="45700" anchor="t" anchorCtr="0">
+            <a:spAutoFit/>
+          </a:bodyPr>
+          <a:lstStyle/>
+          <a:p>
+            <a:pPr lvl="0"/>
+            <a:r>
+              <a:rPr lang="en-US" sz="800" b="1" dirty="0">
+                <a:solidFill>
+                  <a:srgbClr val="7DC1E5"/>
+                </a:solidFill>
+                <a:latin typeface="Calibri"/>
+                <a:ea typeface="Calibri"/>
+                <a:cs typeface="Calibri"/>
+                <a:sym typeface="Calibri"/>
+              </a:rPr>
+              <a:t>✅</a:t>
+            </a:r>
+            <a:r>
+              <a:rPr lang="en-US" sz="900" b="1" i="0" u="none" strike="noStrike" cap="none" dirty="0">
+                <a:solidFill>
+                  <a:srgbClr val="7DC1E5"/>
+                </a:solidFill>
+                <a:latin typeface="Calibri"/>
+                <a:ea typeface="Calibri"/>
+                <a:cs typeface="Calibri"/>
+                <a:sym typeface="Calibri"/>
+              </a:rPr>
+              <a:t>  </a:t>
+            </a:r>
+            <a:r>
+              <a:rPr lang="en-US" sz="900" b="1" i="0" u="none" strike="noStrike" cap="none" dirty="0" err="1">
+                <a:solidFill>
+                  <a:srgbClr val="7DC1E5"/>
+                </a:solidFill>
+                <a:latin typeface="Calibri"/>
+                <a:ea typeface="Calibri"/>
+                <a:cs typeface="Calibri"/>
+                <a:sym typeface="Calibri"/>
+              </a:rPr>
+              <a:t>Objetivo</a:t>
+            </a:r>
+            <a:endParaRPr sz="1700" dirty="0"/>
+          </a:p>
+        </p:txBody>
+      </p:sp>
+      <p:sp>
+        <p:nvSpPr>
+          <p:cNvPr id="15" name="Google Shape;109;p1">
+            <a:extLst>
+              <a:ext uri="{FF2B5EF4-FFF2-40B4-BE49-F238E27FC236}">
+                <a16:creationId xmlns:a16="http://schemas.microsoft.com/office/drawing/2014/main" id="{94D7FDDC-4838-9C5A-1290-D2641F7F2435}"/>
+              </a:ext>
+            </a:extLst>
+          </p:cNvPr>
+          <p:cNvSpPr txBox="1"/>
+          <p:nvPr/>
+        </p:nvSpPr>
+        <p:spPr>
+          <a:xfrm>
+            <a:off x="9742965" y="1690474"/>
+            <a:ext cx="2692800" cy="230700"/>
+          </a:xfrm>
+          <a:prstGeom prst="rect">
+            <a:avLst/>
+          </a:prstGeom>
+          <a:noFill/>
+          <a:ln>
+            <a:noFill/>
+          </a:ln>
+        </p:spPr>
+        <p:txBody>
+          <a:bodyPr spcFirstLastPara="1" wrap="square" lIns="91425" tIns="45700" rIns="91425" bIns="45700" anchor="t" anchorCtr="0">
+            <a:spAutoFit/>
+          </a:bodyPr>
+          <a:lstStyle/>
+          <a:p>
+            <a:pPr lvl="0"/>
+            <a:r>
+              <a:rPr lang="en-US" sz="800" b="1" dirty="0">
+                <a:solidFill>
+                  <a:srgbClr val="7DC1E5"/>
+                </a:solidFill>
+                <a:latin typeface="Calibri"/>
+                <a:ea typeface="Calibri"/>
+                <a:cs typeface="Calibri"/>
+                <a:sym typeface="Calibri"/>
+              </a:rPr>
+              <a:t>✅</a:t>
+            </a:r>
+            <a:r>
+              <a:rPr lang="en-US" sz="900" b="1" i="0" u="none" strike="noStrike" cap="none" dirty="0">
+                <a:solidFill>
+                  <a:srgbClr val="7DC1E5"/>
+                </a:solidFill>
+                <a:latin typeface="Calibri"/>
+                <a:ea typeface="Calibri"/>
+                <a:cs typeface="Calibri"/>
+                <a:sym typeface="Calibri"/>
+              </a:rPr>
+              <a:t>  </a:t>
+            </a:r>
+            <a:r>
+              <a:rPr lang="en-US" sz="900" b="1" i="0" u="none" strike="noStrike" cap="none" dirty="0" err="1">
+                <a:solidFill>
+                  <a:srgbClr val="7DC1E5"/>
+                </a:solidFill>
+                <a:latin typeface="Calibri"/>
+                <a:ea typeface="Calibri"/>
+                <a:cs typeface="Calibri"/>
+                <a:sym typeface="Calibri"/>
+              </a:rPr>
+              <a:t>Objetivo</a:t>
+            </a:r>
+            <a:endParaRPr sz="1700" dirty="0"/>
+          </a:p>
+        </p:txBody>
+      </p:sp>
     </p:spTree>
   </p:cSld>
   <p:clrMapOvr>

</xml_diff>

<commit_message>
feat: 04 - Capacidades/Objetivo lado a lado y negrita blanca; 06 - Dependencia/Fuerza y Objetivo actualizados; PPTX tal cual para descarga
</commit_message>
<xml_diff>
--- a/Presentacion_Anillo_Digital_y_Sensores_Tecnologicos.pptx
+++ b/Presentacion_Anillo_Digital_y_Sensores_Tecnologicos.pptx
@@ -14754,7 +14754,7 @@
           <a:p>
             <a:pPr lvl="0">
               <a:lnSpc>
-                <a:spcPct val="116666"/>
+                <a:spcPct val="100000"/>
               </a:lnSpc>
               <a:spcBef>
                 <a:spcPts val="100"/>
@@ -14795,6 +14795,102 @@
                 <a:sym typeface="Calibri"/>
               </a:rPr>
               <a:t> paso: </a:t>
+            </a:r>
+            <a:r>
+              <a:rPr lang="en-US" sz="800" dirty="0" err="1">
+                <a:solidFill>
+                  <a:srgbClr val="B8B8B8"/>
+                </a:solidFill>
+                <a:latin typeface="Calibri"/>
+                <a:ea typeface="Calibri"/>
+                <a:cs typeface="Calibri"/>
+                <a:sym typeface="Calibri"/>
+              </a:rPr>
+              <a:t>Incorporación</a:t>
+            </a:r>
+            <a:r>
+              <a:rPr lang="en-US" sz="800" dirty="0">
+                <a:solidFill>
+                  <a:srgbClr val="B8B8B8"/>
+                </a:solidFill>
+                <a:latin typeface="Calibri"/>
+                <a:ea typeface="Calibri"/>
+                <a:cs typeface="Calibri"/>
+                <a:sym typeface="Calibri"/>
+              </a:rPr>
+              <a:t> de Sistema ANPR a </a:t>
+            </a:r>
+            <a:r>
+              <a:rPr lang="en-US" sz="800" dirty="0" err="1">
+                <a:solidFill>
+                  <a:srgbClr val="B8B8B8"/>
+                </a:solidFill>
+                <a:latin typeface="Calibri"/>
+                <a:ea typeface="Calibri"/>
+                <a:cs typeface="Calibri"/>
+                <a:sym typeface="Calibri"/>
+              </a:rPr>
+              <a:t>través</a:t>
+            </a:r>
+            <a:r>
+              <a:rPr lang="en-US" sz="800" dirty="0">
+                <a:solidFill>
+                  <a:srgbClr val="B8B8B8"/>
+                </a:solidFill>
+                <a:latin typeface="Calibri"/>
+                <a:ea typeface="Calibri"/>
+                <a:cs typeface="Calibri"/>
+                <a:sym typeface="Calibri"/>
+              </a:rPr>
+              <a:t> de </a:t>
+            </a:r>
+            <a:r>
+              <a:rPr lang="en-US" sz="800" dirty="0" err="1">
+                <a:solidFill>
+                  <a:srgbClr val="B8B8B8"/>
+                </a:solidFill>
+                <a:latin typeface="Calibri"/>
+                <a:ea typeface="Calibri"/>
+                <a:cs typeface="Calibri"/>
+                <a:sym typeface="Calibri"/>
+              </a:rPr>
+              <a:t>dispositivos</a:t>
+            </a:r>
+            <a:r>
+              <a:rPr lang="en-US" sz="800" dirty="0">
+                <a:solidFill>
+                  <a:srgbClr val="B8B8B8"/>
+                </a:solidFill>
+                <a:latin typeface="Calibri"/>
+                <a:ea typeface="Calibri"/>
+                <a:cs typeface="Calibri"/>
+                <a:sym typeface="Calibri"/>
+              </a:rPr>
+              <a:t> </a:t>
+            </a:r>
+            <a:r>
+              <a:rPr lang="en-US" sz="800" dirty="0" err="1">
+                <a:solidFill>
+                  <a:srgbClr val="B8B8B8"/>
+                </a:solidFill>
+                <a:latin typeface="Calibri"/>
+                <a:ea typeface="Calibri"/>
+                <a:cs typeface="Calibri"/>
+                <a:sym typeface="Calibri"/>
+              </a:rPr>
+              <a:t>móviles</a:t>
+            </a:r>
+            <a:r>
+              <a:rPr lang="en-US" sz="800" dirty="0">
+                <a:solidFill>
+                  <a:srgbClr val="B8B8B8"/>
+                </a:solidFill>
+                <a:latin typeface="Calibri"/>
+                <a:ea typeface="Calibri"/>
+                <a:cs typeface="Calibri"/>
+                <a:sym typeface="Calibri"/>
+              </a:rPr>
+              <a:t>. </a:t>
             </a:r>
             <a:endParaRPr sz="800" dirty="0"/>
           </a:p>

</xml_diff>